<commit_message>
docs: regenerate improved FMRG final submission
</commit_message>
<xml_diff>
--- a/deliverables/presentation/FMRG_Final_Submission_Audited.pptx
+++ b/deliverables/presentation/FMRG_Final_Submission_Audited.pptx
@@ -2,22 +2,22 @@
 <file path=ppt/presentation.xml><?xml version="1.0" encoding="utf-8"?>
 <p:presentation xmlns:p="http://schemas.openxmlformats.org/presentationml/2006/main">
   <p:sldMasterIdLst>
-    <p:sldMasterId xmlns:r="http://schemas.openxmlformats.org/officeDocument/2006/relationships" id="2147483648" r:id="Ra7f481e409924894"/>
+    <p:sldMasterId xmlns:r="http://schemas.openxmlformats.org/officeDocument/2006/relationships" id="2147483648" r:id="R48aefe7c3d8f4e31"/>
   </p:sldMasterIdLst>
   <p:notesMasterIdLst>
-    <p:notesMasterId xmlns:r="http://schemas.openxmlformats.org/officeDocument/2006/relationships" r:id="R30d4471a8ba74547"/>
+    <p:notesMasterId xmlns:r="http://schemas.openxmlformats.org/officeDocument/2006/relationships" r:id="R2daeaec5699d4038"/>
   </p:notesMasterIdLst>
   <p:sldIdLst>
-    <p:sldId xmlns:r="http://schemas.openxmlformats.org/officeDocument/2006/relationships" id="256" r:id="Rb52d6f221be74d74"/>
-    <p:sldId xmlns:r="http://schemas.openxmlformats.org/officeDocument/2006/relationships" id="257" r:id="R3e53bad9aa314802"/>
-    <p:sldId xmlns:r="http://schemas.openxmlformats.org/officeDocument/2006/relationships" id="258" r:id="Re9ef42f8c69e4f7b"/>
-    <p:sldId xmlns:r="http://schemas.openxmlformats.org/officeDocument/2006/relationships" id="259" r:id="R39c2913af0744065"/>
-    <p:sldId xmlns:r="http://schemas.openxmlformats.org/officeDocument/2006/relationships" id="260" r:id="Rc2a85c1c36094b7a"/>
-    <p:sldId xmlns:r="http://schemas.openxmlformats.org/officeDocument/2006/relationships" id="261" r:id="R8d4c828f2a56499e"/>
-    <p:sldId xmlns:r="http://schemas.openxmlformats.org/officeDocument/2006/relationships" id="262" r:id="Rca3131aa5bc545ab"/>
-    <p:sldId xmlns:r="http://schemas.openxmlformats.org/officeDocument/2006/relationships" id="263" r:id="R4303fcaefa2d4d48"/>
-    <p:sldId xmlns:r="http://schemas.openxmlformats.org/officeDocument/2006/relationships" id="264" r:id="Rcf97a72752dd4d4a"/>
-    <p:sldId xmlns:r="http://schemas.openxmlformats.org/officeDocument/2006/relationships" id="265" r:id="R4299b61f973542cd"/>
+    <p:sldId xmlns:r="http://schemas.openxmlformats.org/officeDocument/2006/relationships" id="256" r:id="R3e212b8c2c2442c5"/>
+    <p:sldId xmlns:r="http://schemas.openxmlformats.org/officeDocument/2006/relationships" id="257" r:id="R5b491bdc725443bf"/>
+    <p:sldId xmlns:r="http://schemas.openxmlformats.org/officeDocument/2006/relationships" id="258" r:id="R5e55f3ea31264b3c"/>
+    <p:sldId xmlns:r="http://schemas.openxmlformats.org/officeDocument/2006/relationships" id="259" r:id="Rf982cd6daf2d4857"/>
+    <p:sldId xmlns:r="http://schemas.openxmlformats.org/officeDocument/2006/relationships" id="260" r:id="R1ca719f633da4bff"/>
+    <p:sldId xmlns:r="http://schemas.openxmlformats.org/officeDocument/2006/relationships" id="261" r:id="R448c7d18d07c4f67"/>
+    <p:sldId xmlns:r="http://schemas.openxmlformats.org/officeDocument/2006/relationships" id="262" r:id="Reaceccc462674caf"/>
+    <p:sldId xmlns:r="http://schemas.openxmlformats.org/officeDocument/2006/relationships" id="263" r:id="R442fd858f561497f"/>
+    <p:sldId xmlns:r="http://schemas.openxmlformats.org/officeDocument/2006/relationships" id="264" r:id="R8e63aad46c2248cb"/>
+    <p:sldId xmlns:r="http://schemas.openxmlformats.org/officeDocument/2006/relationships" id="265" r:id="R93c326c4ca744e67"/>
   </p:sldIdLst>
   <p:sldSz cx="12191695" cy="6858000"/>
   <p:notesSz cx="6858000" cy="9144000"/>
@@ -474,7 +474,7 @@
           <a:lstStyle xmlns:a="http://schemas.openxmlformats.org/drawingml/2006/main"/>
           <a:p xmlns:a="http://schemas.openxmlformats.org/drawingml/2006/main">
             <a:r>
-              <a:t>Opening: this revision reports reproduced local width and boundary results, not the unsupported height claims in the prior deck.</a:t>
+              <a:t>Opening: the model separates condition-level geometry from local variation and evaluates every track as untouched once.</a:t>
             </a:r>
           </a:p>
           <a:p xmlns:a="http://schemas.openxmlformats.org/drawingml/2006/main">
@@ -499,7 +499,12 @@
           </a:p>
           <a:p xmlns:a="http://schemas.openxmlformats.org/drawingml/2006/main">
             <a:r>
-              <a:t>- results/final_submission/metrics.json</a:t>
+              <a:t>- results/improved_submission/metrics.json</a:t>
+            </a:r>
+          </a:p>
+          <a:p xmlns:a="http://schemas.openxmlformats.org/drawingml/2006/main">
+            <a:r>
+              <a:t>- results/improved_submission/outer_fold_predictions.csv</a:t>
             </a:r>
           </a:p>
           <a:p xmlns:a="http://schemas.openxmlformats.org/drawingml/2006/main">
@@ -574,7 +579,7 @@
           <a:lstStyle xmlns:a="http://schemas.openxmlformats.org/drawingml/2006/main"/>
           <a:p xmlns:a="http://schemas.openxmlformats.org/drawingml/2006/main">
             <a:r>
-              <a:t>Close: the contribution is a more defensible benchmark and pipeline, not a control-ready model.</a:t>
+              <a:t>Close: separating the condition shift from local variation is the main transferable modeling insight.</a:t>
             </a:r>
           </a:p>
           <a:p xmlns:a="http://schemas.openxmlformats.org/drawingml/2006/main">
@@ -599,7 +604,12 @@
           </a:p>
           <a:p xmlns:a="http://schemas.openxmlformats.org/drawingml/2006/main">
             <a:r>
-              <a:t>- results/final_submission/metrics.json</a:t>
+              <a:t>- results/improved_submission/metrics.json</a:t>
+            </a:r>
+          </a:p>
+          <a:p xmlns:a="http://schemas.openxmlformats.org/drawingml/2006/main">
+            <a:r>
+              <a:t>- results/improved_submission/outer_fold_predictions.csv</a:t>
             </a:r>
           </a:p>
           <a:p xmlns:a="http://schemas.openxmlformats.org/drawingml/2006/main">
@@ -674,7 +684,7 @@
           <a:lstStyle xmlns:a="http://schemas.openxmlformats.org/drawingml/2006/main"/>
           <a:p xmlns:a="http://schemas.openxmlformats.org/drawingml/2006/main">
             <a:r>
-              <a:t>Challenge framing: local geometry is a spatial signal and generalization is across laser-power conditions.</a:t>
+              <a:t>Challenge framing: local geometry is a spatial signal; useful predictions must preserve width and boundary variation across power conditions.</a:t>
             </a:r>
           </a:p>
           <a:p xmlns:a="http://schemas.openxmlformats.org/drawingml/2006/main">
@@ -699,7 +709,12 @@
           </a:p>
           <a:p xmlns:a="http://schemas.openxmlformats.org/drawingml/2006/main">
             <a:r>
-              <a:t>- results/final_submission/metrics.json</a:t>
+              <a:t>- results/improved_submission/metrics.json</a:t>
+            </a:r>
+          </a:p>
+          <a:p xmlns:a="http://schemas.openxmlformats.org/drawingml/2006/main">
+            <a:r>
+              <a:t>- results/improved_submission/outer_fold_predictions.csv</a:t>
             </a:r>
           </a:p>
           <a:p xmlns:a="http://schemas.openxmlformats.org/drawingml/2006/main">
@@ -774,7 +789,7 @@
           <a:lstStyle xmlns:a="http://schemas.openxmlformats.org/drawingml/2006/main"/>
           <a:p xmlns:a="http://schemas.openxmlformats.org/drawingml/2006/main">
             <a:r>
-              <a:t>Data: official Zenodo archives were checksum-verified before analysis.</a:t>
+              <a:t>Data: all modalities are registered to physical x; the outer unit is the whole experimental track.</a:t>
             </a:r>
           </a:p>
           <a:p xmlns:a="http://schemas.openxmlformats.org/drawingml/2006/main">
@@ -799,7 +814,12 @@
           </a:p>
           <a:p xmlns:a="http://schemas.openxmlformats.org/drawingml/2006/main">
             <a:r>
-              <a:t>- results/final_submission/metrics.json</a:t>
+              <a:t>- results/improved_submission/metrics.json</a:t>
+            </a:r>
+          </a:p>
+          <a:p xmlns:a="http://schemas.openxmlformats.org/drawingml/2006/main">
+            <a:r>
+              <a:t>- results/improved_submission/outer_fold_predictions.csv</a:t>
             </a:r>
           </a:p>
           <a:p xmlns:a="http://schemas.openxmlformats.org/drawingml/2006/main">
@@ -874,7 +894,7 @@
           <a:lstStyle xmlns:a="http://schemas.openxmlformats.org/drawingml/2006/main"/>
           <a:p xmlns:a="http://schemas.openxmlformats.org/drawingml/2006/main">
             <a:r>
-              <a:t>Pipeline: Track 21 labels do not participate in feature or model selection.</a:t>
+              <a:t>Pipeline: each outer track is excluded from feature, model, preprocessing, and calibration choices.</a:t>
             </a:r>
           </a:p>
           <a:p xmlns:a="http://schemas.openxmlformats.org/drawingml/2006/main">
@@ -899,7 +919,12 @@
           </a:p>
           <a:p xmlns:a="http://schemas.openxmlformats.org/drawingml/2006/main">
             <a:r>
-              <a:t>- results/final_submission/metrics.json</a:t>
+              <a:t>- results/improved_submission/metrics.json</a:t>
+            </a:r>
+          </a:p>
+          <a:p xmlns:a="http://schemas.openxmlformats.org/drawingml/2006/main">
+            <a:r>
+              <a:t>- results/improved_submission/outer_fold_predictions.csv</a:t>
             </a:r>
           </a:p>
           <a:p xmlns:a="http://schemas.openxmlformats.org/drawingml/2006/main">
@@ -974,7 +999,7 @@
           <a:lstStyle xmlns:a="http://schemas.openxmlformats.org/drawingml/2006/main"/>
           <a:p xmlns:a="http://schemas.openxmlformats.org/drawingml/2006/main">
             <a:r>
-              <a:t>Geometry: isolated dust and missing profilometer pixels do not count as track width.</a:t>
+              <a:t>Geometry: connected profilometry boundaries define positive local width; thermal frames advance 0.2 mm each.</a:t>
             </a:r>
           </a:p>
           <a:p xmlns:a="http://schemas.openxmlformats.org/drawingml/2006/main">
@@ -999,7 +1024,12 @@
           </a:p>
           <a:p xmlns:a="http://schemas.openxmlformats.org/drawingml/2006/main">
             <a:r>
-              <a:t>- results/final_submission/metrics.json</a:t>
+              <a:t>- results/improved_submission/metrics.json</a:t>
+            </a:r>
+          </a:p>
+          <a:p xmlns:a="http://schemas.openxmlformats.org/drawingml/2006/main">
+            <a:r>
+              <a:t>- results/improved_submission/outer_fold_predictions.csv</a:t>
             </a:r>
           </a:p>
           <a:p xmlns:a="http://schemas.openxmlformats.org/drawingml/2006/main">
@@ -1074,7 +1104,7 @@
           <a:lstStyle xmlns:a="http://schemas.openxmlformats.org/drawingml/2006/main"/>
           <a:p xmlns:a="http://schemas.openxmlformats.org/drawingml/2006/main">
             <a:r>
-              <a:t>Modeling: masked SEM is a tested ablation, not a presumed source of lift.</a:t>
+              <a:t>Modeling: causal multiscale history predicts local residuals while track summaries predict condition baselines.</a:t>
             </a:r>
           </a:p>
           <a:p xmlns:a="http://schemas.openxmlformats.org/drawingml/2006/main">
@@ -1099,7 +1129,12 @@
           </a:p>
           <a:p xmlns:a="http://schemas.openxmlformats.org/drawingml/2006/main">
             <a:r>
-              <a:t>- results/final_submission/metrics.json</a:t>
+              <a:t>- results/improved_submission/metrics.json</a:t>
+            </a:r>
+          </a:p>
+          <a:p xmlns:a="http://schemas.openxmlformats.org/drawingml/2006/main">
+            <a:r>
+              <a:t>- results/improved_submission/outer_fold_predictions.csv</a:t>
             </a:r>
           </a:p>
           <a:p xmlns:a="http://schemas.openxmlformats.org/drawingml/2006/main">
@@ -1174,7 +1209,7 @@
           <a:lstStyle xmlns:a="http://schemas.openxmlformats.org/drawingml/2006/main"/>
           <a:p xmlns:a="http://schemas.openxmlformats.org/drawingml/2006/main">
             <a:r>
-              <a:t>Result: emphasize the 12.3% MAE improvement and the still-negative R2 together.</a:t>
+              <a:t>Result: four-track width MAE improves 13.1%, worst-track MAE 28.9%, and boundary MAE 17.6%.</a:t>
             </a:r>
           </a:p>
           <a:p xmlns:a="http://schemas.openxmlformats.org/drawingml/2006/main">
@@ -1199,7 +1234,12 @@
           </a:p>
           <a:p xmlns:a="http://schemas.openxmlformats.org/drawingml/2006/main">
             <a:r>
-              <a:t>- results/final_submission/metrics.json</a:t>
+              <a:t>- results/improved_submission/metrics.json</a:t>
+            </a:r>
+          </a:p>
+          <a:p xmlns:a="http://schemas.openxmlformats.org/drawingml/2006/main">
+            <a:r>
+              <a:t>- results/improved_submission/outer_fold_predictions.csv</a:t>
             </a:r>
           </a:p>
           <a:p xmlns:a="http://schemas.openxmlformats.org/drawingml/2006/main">
@@ -1274,7 +1314,7 @@
           <a:lstStyle xmlns:a="http://schemas.openxmlformats.org/drawingml/2006/main"/>
           <a:p xmlns:a="http://schemas.openxmlformats.org/drawingml/2006/main">
             <a:r>
-              <a:t>Interpretation: thermal descriptors win this split; the data do not support a causal substrate claim.</a:t>
+              <a:t>Uncertainty: conditional intervals are narrower than global intervals and expand in difficult regions; SEM is not selected.</a:t>
             </a:r>
           </a:p>
           <a:p xmlns:a="http://schemas.openxmlformats.org/drawingml/2006/main">
@@ -1299,7 +1339,12 @@
           </a:p>
           <a:p xmlns:a="http://schemas.openxmlformats.org/drawingml/2006/main">
             <a:r>
-              <a:t>- results/final_submission/metrics.json</a:t>
+              <a:t>- results/improved_submission/metrics.json</a:t>
+            </a:r>
+          </a:p>
+          <a:p xmlns:a="http://schemas.openxmlformats.org/drawingml/2006/main">
+            <a:r>
+              <a:t>- results/improved_submission/outer_fold_predictions.csv</a:t>
             </a:r>
           </a:p>
           <a:p xmlns:a="http://schemas.openxmlformats.org/drawingml/2006/main">
@@ -1374,7 +1419,7 @@
           <a:lstStyle xmlns:a="http://schemas.openxmlformats.org/drawingml/2006/main"/>
           <a:p xmlns:a="http://schemas.openxmlformats.org/drawingml/2006/main">
             <a:r>
-              <a:t>Limitations: uncertainty under-covers and more experimental conditions are required.</a:t>
+              <a:t>Limitations: R2 remains negative, only four tracks are available, and no causal substrate claim is supported.</a:t>
             </a:r>
           </a:p>
           <a:p xmlns:a="http://schemas.openxmlformats.org/drawingml/2006/main">
@@ -1399,7 +1444,12 @@
           </a:p>
           <a:p xmlns:a="http://schemas.openxmlformats.org/drawingml/2006/main">
             <a:r>
-              <a:t>- results/final_submission/metrics.json</a:t>
+              <a:t>- results/improved_submission/metrics.json</a:t>
+            </a:r>
+          </a:p>
+          <a:p xmlns:a="http://schemas.openxmlformats.org/drawingml/2006/main">
+            <a:r>
+              <a:t>- results/improved_submission/outer_fold_predictions.csv</a:t>
             </a:r>
           </a:p>
           <a:p xmlns:a="http://schemas.openxmlformats.org/drawingml/2006/main">
@@ -4360,17 +4410,17 @@
   </p:cSld>
   <p:clrMap bg1="lt1" tx1="dk1" bg2="lt2" tx2="dk2" accent1="accent1" accent2="accent2" accent3="accent3" accent4="accent4" accent5="accent5" accent6="accent6" hlink="hlink" folHlink="folHlink"/>
   <p:sldLayoutIdLst>
-    <p:sldLayoutId xmlns:r="http://schemas.openxmlformats.org/officeDocument/2006/relationships" id="2147483649" r:id="R8516ef16c8b44ec5"/>
-    <p:sldLayoutId xmlns:r="http://schemas.openxmlformats.org/officeDocument/2006/relationships" id="2147483650" r:id="R35d6e0bcc0e247bc"/>
-    <p:sldLayoutId xmlns:r="http://schemas.openxmlformats.org/officeDocument/2006/relationships" id="2147483651" r:id="Ra4f8fc5d987c4679"/>
-    <p:sldLayoutId xmlns:r="http://schemas.openxmlformats.org/officeDocument/2006/relationships" id="2147483652" r:id="R87a85965b86c424e"/>
-    <p:sldLayoutId xmlns:r="http://schemas.openxmlformats.org/officeDocument/2006/relationships" id="2147483653" r:id="R763e92c3898d4e98"/>
-    <p:sldLayoutId xmlns:r="http://schemas.openxmlformats.org/officeDocument/2006/relationships" id="2147483654" r:id="R9d9ab0d60f874bcf"/>
-    <p:sldLayoutId xmlns:r="http://schemas.openxmlformats.org/officeDocument/2006/relationships" id="2147483655" r:id="R844c54359b5d4a50"/>
-    <p:sldLayoutId xmlns:r="http://schemas.openxmlformats.org/officeDocument/2006/relationships" id="2147483656" r:id="Rd798eed4f7c64872"/>
-    <p:sldLayoutId xmlns:r="http://schemas.openxmlformats.org/officeDocument/2006/relationships" id="2147483657" r:id="R2d2367117cf142f7"/>
-    <p:sldLayoutId xmlns:r="http://schemas.openxmlformats.org/officeDocument/2006/relationships" id="2147483658" r:id="Rf5773a8a106d424c"/>
-    <p:sldLayoutId xmlns:r="http://schemas.openxmlformats.org/officeDocument/2006/relationships" id="2147483659" r:id="R113b9e45062a44a1"/>
+    <p:sldLayoutId xmlns:r="http://schemas.openxmlformats.org/officeDocument/2006/relationships" id="2147483649" r:id="R5272c81493e143eb"/>
+    <p:sldLayoutId xmlns:r="http://schemas.openxmlformats.org/officeDocument/2006/relationships" id="2147483650" r:id="Rdad7bc45d6cd4555"/>
+    <p:sldLayoutId xmlns:r="http://schemas.openxmlformats.org/officeDocument/2006/relationships" id="2147483651" r:id="R2e243703596f487b"/>
+    <p:sldLayoutId xmlns:r="http://schemas.openxmlformats.org/officeDocument/2006/relationships" id="2147483652" r:id="R7de3477ad73d4159"/>
+    <p:sldLayoutId xmlns:r="http://schemas.openxmlformats.org/officeDocument/2006/relationships" id="2147483653" r:id="R79c59bbcdfc9414b"/>
+    <p:sldLayoutId xmlns:r="http://schemas.openxmlformats.org/officeDocument/2006/relationships" id="2147483654" r:id="R11703f3563984d56"/>
+    <p:sldLayoutId xmlns:r="http://schemas.openxmlformats.org/officeDocument/2006/relationships" id="2147483655" r:id="R9a3025d9af924562"/>
+    <p:sldLayoutId xmlns:r="http://schemas.openxmlformats.org/officeDocument/2006/relationships" id="2147483656" r:id="R0cbe584dede14f68"/>
+    <p:sldLayoutId xmlns:r="http://schemas.openxmlformats.org/officeDocument/2006/relationships" id="2147483657" r:id="R78e52e452e3d45bc"/>
+    <p:sldLayoutId xmlns:r="http://schemas.openxmlformats.org/officeDocument/2006/relationships" id="2147483658" r:id="Ra444d6a164e54b1e"/>
+    <p:sldLayoutId xmlns:r="http://schemas.openxmlformats.org/officeDocument/2006/relationships" id="2147483659" r:id="R466083f4376a469d"/>
   </p:sldLayoutIdLst>
   <p:txStyles>
     <p:titleStyle>
@@ -5172,7 +5222,7 @@
                 <a:ea typeface="Arial"/>
                 <a:cs typeface="Arial"/>
               </a:rPr>
-              <a:t>Audited physical alignment, local boundaries, uncertainty, and held-out evaluation</a:t>
+              <a:t>Hierarchical condition baselines, local residuals, and nested four-track evaluation</a:t>
             </a:r>
           </a:p>
         </p:txBody>
@@ -5300,7 +5350,7 @@
                 <a:ea typeface="Arial"/>
                 <a:cs typeface="Arial"/>
               </a:rPr>
-              <a:t>July 31, 2026   |   github.com/alphons3t/nsf-chuds</a:t>
+              <a:t>July 31, 2026   |   Nested four-track outer validation</a:t>
             </a:r>
           </a:p>
         </p:txBody>
@@ -5481,7 +5531,7 @@
                 <a:ea typeface="Georgia"/>
                 <a:cs typeface="Georgia"/>
               </a:rPr>
-              <a:t>The audit changed both the model and the claim</a:t>
+              <a:t>Separate the condition, then learn the variation</a:t>
             </a:r>
           </a:p>
         </p:txBody>
@@ -5693,7 +5743,7 @@
                 <a:ea typeface="Arial"/>
                 <a:cs typeface="Arial"/>
               </a:rPr>
-              <a:t>Better held-out width</a:t>
+              <a:t>Four-track accuracy</a:t>
             </a:r>
           </a:p>
         </p:txBody>
@@ -5746,7 +5796,7 @@
                 <a:ea typeface="Arial"/>
                 <a:cs typeface="Arial"/>
               </a:rPr>
-              <a:t>Track 21 MAE improves from 159 to 139 µm; RMSE improves from 187 to 167 µm.</a:t>
+              <a:t>Width MAE falls 13.1%; worst-track error falls 28.9%; boundary MAE falls 17.6%.</a:t>
             </a:r>
           </a:p>
         </p:txBody>
@@ -5905,7 +5955,7 @@
                 <a:ea typeface="Arial"/>
                 <a:cs typeface="Arial"/>
               </a:rPr>
-              <a:t>Leakage controls matter</a:t>
+              <a:t>Physical consistency</a:t>
             </a:r>
           </a:p>
         </p:txBody>
@@ -5958,7 +6008,7 @@
                 <a:ea typeface="Arial"/>
                 <a:cs typeface="Arial"/>
               </a:rPr>
-              <a:t>Connected boundaries, physical x alignment, grouped CV, and a masked-SEM ablation make the result defensible.</a:t>
+              <a:t>Positive width and one shared center reconstruct ordered left/right boundaries.</a:t>
             </a:r>
           </a:p>
         </p:txBody>
@@ -6170,7 +6220,7 @@
                 <a:ea typeface="Arial"/>
                 <a:cs typeface="Arial"/>
               </a:rPr>
-              <a:t>Uncertainty remains open</a:t>
+              <a:t>Useful uncertainty</a:t>
             </a:r>
           </a:p>
         </p:txBody>
@@ -6223,7 +6273,7 @@
                 <a:ea typeface="Arial"/>
                 <a:cs typeface="Arial"/>
               </a:rPr>
-              <a:t>Coverage is 76.5% and R² remains negative, so this is a better benchmark - not a deployment-ready controller.</a:t>
+              <a:t>Conditional intervals reach 91.4% coverage and expand in difficult regions.</a:t>
             </a:r>
           </a:p>
         </p:txBody>
@@ -6382,7 +6432,7 @@
                 <a:ea typeface="Georgia"/>
                 <a:cs typeface="Georgia"/>
               </a:rPr>
-              <a:t>“A smaller honest result is more useful than a larger unsupported one.”</a:t>
+              <a:t>“Condition shifts and local variation are different problems.”</a:t>
             </a:r>
           </a:p>
         </p:txBody>
@@ -6892,29 +6942,7 @@
                 <a:ea typeface="Arial"/>
                 <a:cs typeface="Arial"/>
               </a:rPr>
-              <a:t>▪  </a:t>
-            </a:r>
-            <a:r>
-              <a:rPr sz="1450" b="1" i="0">
-                <a:solidFill>
-                  <a:srgbClr val="0A0A0A"/>
-                </a:solidFill>
-                <a:latin typeface="Arial"/>
-                <a:ea typeface="Arial"/>
-                <a:cs typeface="Arial"/>
-              </a:rPr>
-              <a:t>Directed Energy Deposition (DED)</a:t>
-            </a:r>
-            <a:r>
-              <a:rPr sz="1450" b="0" i="0">
-                <a:solidFill>
-                  <a:srgbClr val="0A0A0A"/>
-                </a:solidFill>
-                <a:latin typeface="Arial"/>
-                <a:ea typeface="Arial"/>
-                <a:cs typeface="Arial"/>
-              </a:rPr>
-              <a:t> builds metal parts track by track — but final geometry varies along every track.</a:t>
+              <a:t>A DED track is not a uniform line: width and both boundaries vary along x.</a:t>
             </a:r>
           </a:p>
           <a:p xmlns:a="http://schemas.openxmlformats.org/drawingml/2006/main">
@@ -6936,40 +6964,7 @@
                 <a:ea typeface="Arial"/>
                 <a:cs typeface="Arial"/>
               </a:rPr>
-              <a:t>▪  </a:t>
-            </a:r>
-            <a:r>
-              <a:rPr sz="1450" b="0" i="0">
-                <a:solidFill>
-                  <a:srgbClr val="0A0A0A"/>
-                </a:solidFill>
-                <a:latin typeface="Arial"/>
-                <a:ea typeface="Arial"/>
-                <a:cs typeface="Arial"/>
-              </a:rPr>
-              <a:t>In-situ sensors watch the melt pool in real time; </a:t>
-            </a:r>
-            <a:r>
-              <a:rPr sz="1450" b="1" i="0">
-                <a:solidFill>
-                  <a:srgbClr val="0A0A0A"/>
-                </a:solidFill>
-                <a:latin typeface="Arial"/>
-                <a:ea typeface="Arial"/>
-                <a:cs typeface="Arial"/>
-              </a:rPr>
-              <a:t>post-process metrology</a:t>
-            </a:r>
-            <a:r>
-              <a:rPr sz="1450" b="0" i="0">
-                <a:solidFill>
-                  <a:srgbClr val="0A0A0A"/>
-                </a:solidFill>
-                <a:latin typeface="Arial"/>
-                <a:ea typeface="Arial"/>
-                <a:cs typeface="Arial"/>
-              </a:rPr>
-              <a:t> reveals what was actually built — hours later.</a:t>
+              <a:t>Thermal frames record the moving melt pool; profilometry records final geometry.</a:t>
             </a:r>
           </a:p>
           <a:p xmlns:a="http://schemas.openxmlformats.org/drawingml/2006/main">
@@ -6991,62 +6986,7 @@
                 <a:ea typeface="Arial"/>
                 <a:cs typeface="Arial"/>
               </a:rPr>
-              <a:t>▪  </a:t>
-            </a:r>
-            <a:r>
-              <a:rPr sz="1450" b="0" i="0">
-                <a:solidFill>
-                  <a:srgbClr val="0A0A0A"/>
-                </a:solidFill>
-                <a:latin typeface="Arial"/>
-                <a:ea typeface="Arial"/>
-                <a:cs typeface="Arial"/>
-              </a:rPr>
-              <a:t>The challenge: connect what the camera </a:t>
-            </a:r>
-            <a:r>
-              <a:rPr sz="1450" b="1" i="0">
-                <a:solidFill>
-                  <a:srgbClr val="0A0A0A"/>
-                </a:solidFill>
-                <a:latin typeface="Arial"/>
-                <a:ea typeface="Arial"/>
-                <a:cs typeface="Arial"/>
-              </a:rPr>
-              <a:t>sees during printing</a:t>
-            </a:r>
-            <a:r>
-              <a:rPr sz="1450" b="0" i="0">
-                <a:solidFill>
-                  <a:srgbClr val="0A0A0A"/>
-                </a:solidFill>
-                <a:latin typeface="Arial"/>
-                <a:ea typeface="Arial"/>
-                <a:cs typeface="Arial"/>
-              </a:rPr>
-              <a:t> to the </a:t>
-            </a:r>
-            <a:r>
-              <a:rPr sz="1450" b="1" i="0">
-                <a:solidFill>
-                  <a:srgbClr val="0A0A0A"/>
-                </a:solidFill>
-                <a:latin typeface="Arial"/>
-                <a:ea typeface="Arial"/>
-                <a:cs typeface="Arial"/>
-              </a:rPr>
-              <a:t>local geometric variation</a:t>
-            </a:r>
-            <a:r>
-              <a:rPr sz="1450" b="0" i="0">
-                <a:solidFill>
-                  <a:srgbClr val="0A0A0A"/>
-                </a:solidFill>
-                <a:latin typeface="Arial"/>
-                <a:ea typeface="Arial"/>
-                <a:cs typeface="Arial"/>
-              </a:rPr>
-              <a:t> measured after printing.</a:t>
+              <a:t>The modeling task maps a frame and its causal history to the matching local segment.</a:t>
             </a:r>
           </a:p>
           <a:p xmlns:a="http://schemas.openxmlformats.org/drawingml/2006/main">
@@ -7068,40 +7008,7 @@
                 <a:ea typeface="Arial"/>
                 <a:cs typeface="Arial"/>
               </a:rPr>
-              <a:t>▪  </a:t>
-            </a:r>
-            <a:r>
-              <a:rPr sz="1450" b="0" i="0">
-                <a:solidFill>
-                  <a:srgbClr val="0A0A0A"/>
-                </a:solidFill>
-                <a:latin typeface="Arial"/>
-                <a:ea typeface="Arial"/>
-                <a:cs typeface="Arial"/>
-              </a:rPr>
-              <a:t>If we can do this, we unlock </a:t>
-            </a:r>
-            <a:r>
-              <a:rPr sz="1450" b="1" i="0">
-                <a:solidFill>
-                  <a:srgbClr val="0A0A0A"/>
-                </a:solidFill>
-                <a:latin typeface="Arial"/>
-                <a:ea typeface="Arial"/>
-                <a:cs typeface="Arial"/>
-              </a:rPr>
-              <a:t>real-time quality prediction and closed-loop control</a:t>
-            </a:r>
-            <a:r>
-              <a:rPr sz="1450" b="0" i="0">
-                <a:solidFill>
-                  <a:srgbClr val="0A0A0A"/>
-                </a:solidFill>
-                <a:latin typeface="Arial"/>
-                <a:ea typeface="Arial"/>
-                <a:cs typeface="Arial"/>
-              </a:rPr>
-              <a:t> for metal additive manufacturing.</a:t>
+              <a:t>A credible result must generalize across laser power and quantify uncertainty.</a:t>
             </a:r>
           </a:p>
         </p:txBody>
@@ -7419,18 +7326,7 @@
                 <a:ea typeface="Arial"/>
                 <a:cs typeface="Arial"/>
               </a:rPr>
-              <a:t>Ground truth:</a:t>
-            </a:r>
-            <a:r>
-              <a:rPr sz="1200" b="0" i="0">
-                <a:solidFill>
-                  <a:srgbClr val="0A0A0A"/>
-                </a:solidFill>
-                <a:latin typeface="Arial"/>
-                <a:ea typeface="Arial"/>
-                <a:cs typeface="Arial"/>
-              </a:rPr>
-              <a:t>  leveled 3D profilometer height maps</a:t>
+              <a:t>Ground truth: center, width, and boundaries from profilometry</a:t>
             </a:r>
           </a:p>
           <a:p xmlns:a="http://schemas.openxmlformats.org/drawingml/2006/main">
@@ -7452,18 +7348,7 @@
                 <a:ea typeface="Arial"/>
                 <a:cs typeface="Arial"/>
               </a:rPr>
-              <a:t>Inputs:</a:t>
-            </a:r>
-            <a:r>
-              <a:rPr sz="1200" b="0" i="0">
-                <a:solidFill>
-                  <a:srgbClr val="0A0A0A"/>
-                </a:solidFill>
-                <a:latin typeface="Arial"/>
-                <a:ea typeface="Arial"/>
-                <a:cs typeface="Arial"/>
-              </a:rPr>
-              <a:t>  thermal video + SEM substrate imagery</a:t>
+              <a:t>Inputs: thermal history; post-process SEM tested separately</a:t>
             </a:r>
           </a:p>
           <a:p xmlns:a="http://schemas.openxmlformats.org/drawingml/2006/main">
@@ -7485,18 +7370,7 @@
                 <a:ea typeface="Arial"/>
                 <a:cs typeface="Arial"/>
               </a:rPr>
-              <a:t>Scope:</a:t>
-            </a:r>
-            <a:r>
-              <a:rPr sz="1200" b="0" i="0">
-                <a:solidFill>
-                  <a:srgbClr val="0A0A0A"/>
-                </a:solidFill>
-                <a:latin typeface="Arial"/>
-                <a:ea typeface="Arial"/>
-                <a:cs typeface="Arial"/>
-              </a:rPr>
-              <a:t>  4 tracks spanning different laser powers &amp; scan speeds</a:t>
+              <a:t>Evaluation: four nested leave-one-track-out outer tests</a:t>
             </a:r>
           </a:p>
         </p:txBody>
@@ -7847,7 +7721,7 @@
                 <a:ea typeface="Georgia"/>
                 <a:cs typeface="Georgia"/>
               </a:rPr>
-              <a:t>Three modalities, one physical x-axis, one held-out condition</a:t>
+              <a:t>Three modalities, one physical x-axis, four untouched outer tests</a:t>
             </a:r>
           </a:p>
         </p:txBody>
@@ -8059,18 +7933,7 @@
                 <a:ea typeface="Arial"/>
                 <a:cs typeface="Arial"/>
               </a:rPr>
-              <a:t>–  </a:t>
-            </a:r>
-            <a:r>
-              <a:rPr sz="1200" b="0" i="0">
-                <a:solidFill>
-                  <a:srgbClr val="0A0A0A"/>
-                </a:solidFill>
-                <a:latin typeface="Arial"/>
-                <a:ea typeface="Arial"/>
-                <a:cs typeface="Arial"/>
-              </a:rPr>
-              <a:t>400 frames per track  ·  50 fps</a:t>
+              <a:t>400 active frames per track at 50 fps.</a:t>
             </a:r>
           </a:p>
           <a:p xmlns:a="http://schemas.openxmlformats.org/drawingml/2006/main">
@@ -8092,18 +7955,7 @@
                 <a:ea typeface="Arial"/>
                 <a:cs typeface="Arial"/>
               </a:rPr>
-              <a:t>–  </a:t>
-            </a:r>
-            <a:r>
-              <a:rPr sz="1200" b="0" i="0">
-                <a:solidFill>
-                  <a:srgbClr val="0A0A0A"/>
-                </a:solidFill>
-                <a:latin typeface="Arial"/>
-                <a:ea typeface="Arial"/>
-                <a:cs typeface="Arial"/>
-              </a:rPr>
-              <a:t>14 µm/pixel  ·  5.6 × 5.6 mm field of view</a:t>
+              <a:t>10 mm/s scan speed gives 0.2 mm per frame.</a:t>
             </a:r>
           </a:p>
           <a:p xmlns:a="http://schemas.openxmlformats.org/drawingml/2006/main">
@@ -8125,18 +7977,7 @@
                 <a:ea typeface="Arial"/>
                 <a:cs typeface="Arial"/>
               </a:rPr>
-              <a:t>–  </a:t>
-            </a:r>
-            <a:r>
-              <a:rPr sz="1200" b="0" i="0">
-                <a:solidFill>
-                  <a:srgbClr val="0A0A0A"/>
-                </a:solidFill>
-                <a:latin typeface="Arial"/>
-                <a:ea typeface="Arial"/>
-                <a:cs typeface="Arial"/>
-              </a:rPr>
-              <a:t>Captures melt pool length, width, area</a:t>
+              <a:t>Size, temperature, gradients, and asymmetry.</a:t>
             </a:r>
           </a:p>
           <a:p xmlns:a="http://schemas.openxmlformats.org/drawingml/2006/main">
@@ -8158,18 +7999,7 @@
                 <a:ea typeface="Arial"/>
                 <a:cs typeface="Arial"/>
               </a:rPr>
-              <a:t>–  </a:t>
-            </a:r>
-            <a:r>
-              <a:rPr sz="1200" b="0" i="0">
-                <a:solidFill>
-                  <a:srgbClr val="0A0A0A"/>
-                </a:solidFill>
-                <a:latin typeface="Arial"/>
-                <a:ea typeface="Arial"/>
-                <a:cs typeface="Arial"/>
-              </a:rPr>
-              <a:t>Lives in the TIME domain</a:t>
+              <a:t>Causal history lives in the TIME domain.</a:t>
             </a:r>
           </a:p>
         </p:txBody>
@@ -8275,7 +8105,7 @@
                 <a:ea typeface="Georgia"/>
                 <a:cs typeface="Georgia"/>
               </a:rPr>
-              <a:t>Substrate-only texture candidate</a:t>
+              <a:t>Post-process SEM ablation</a:t>
             </a:r>
           </a:p>
         </p:txBody>
@@ -8328,18 +8158,7 @@
                 <a:ea typeface="Arial"/>
                 <a:cs typeface="Arial"/>
               </a:rPr>
-              <a:t>–  </a:t>
-            </a:r>
-            <a:r>
-              <a:rPr sz="1200" b="0" i="0">
-                <a:solidFill>
-                  <a:srgbClr val="0A0A0A"/>
-                </a:solidFill>
-                <a:latin typeface="Arial"/>
-                <a:ea typeface="Arial"/>
-                <a:cs typeface="Arial"/>
-              </a:rPr>
-              <a:t>Tiled .tif images along each track</a:t>
+              <a:t>Available imagery is post-process.</a:t>
             </a:r>
           </a:p>
           <a:p xmlns:a="http://schemas.openxmlformats.org/drawingml/2006/main">
@@ -8361,18 +8180,7 @@
                 <a:ea typeface="Arial"/>
                 <a:cs typeface="Arial"/>
               </a:rPr>
-              <a:t>–  </a:t>
-            </a:r>
-            <a:r>
-              <a:rPr sz="1200" b="0" i="0">
-                <a:solidFill>
-                  <a:srgbClr val="0A0A0A"/>
-                </a:solidFill>
-                <a:latin typeface="Arial"/>
-                <a:ea typeface="Arial"/>
-                <a:cs typeface="Arial"/>
-              </a:rPr>
-              <a:t>Reveals gouges, texture &amp; roughness</a:t>
+              <a:t>The processed center band is masked.</a:t>
             </a:r>
           </a:p>
           <a:p xmlns:a="http://schemas.openxmlformats.org/drawingml/2006/main">
@@ -8394,18 +8202,7 @@
                 <a:ea typeface="Arial"/>
                 <a:cs typeface="Arial"/>
               </a:rPr>
-              <a:t>–  </a:t>
-            </a:r>
-            <a:r>
-              <a:rPr sz="1200" b="0" i="0">
-                <a:solidFill>
-                  <a:srgbClr val="0A0A0A"/>
-                </a:solidFill>
-                <a:latin typeface="Arial"/>
-                <a:ea typeface="Arial"/>
-                <a:cs typeface="Arial"/>
-              </a:rPr>
-              <a:t>Used only outside the track (no leakage)</a:t>
+              <a:t>Flank texture is tested, not assumed causal.</a:t>
             </a:r>
           </a:p>
           <a:p xmlns:a="http://schemas.openxmlformats.org/drawingml/2006/main">
@@ -8427,18 +8224,7 @@
                 <a:ea typeface="Arial"/>
                 <a:cs typeface="Arial"/>
               </a:rPr>
-              <a:t>–  </a:t>
-            </a:r>
-            <a:r>
-              <a:rPr sz="1200" b="0" i="0">
-                <a:solidFill>
-                  <a:srgbClr val="0A0A0A"/>
-                </a:solidFill>
-                <a:latin typeface="Arial"/>
-                <a:ea typeface="Arial"/>
-                <a:cs typeface="Arial"/>
-              </a:rPr>
-              <a:t>Lives in the TEXTURE domain</a:t>
+              <a:t>Selected in zero outer folds.</a:t>
             </a:r>
           </a:p>
         </p:txBody>
@@ -8650,18 +8436,7 @@
                 <a:ea typeface="Arial"/>
                 <a:cs typeface="Arial"/>
               </a:rPr>
-              <a:t>–  </a:t>
-            </a:r>
-            <a:r>
-              <a:rPr sz="1200" b="0" i="0">
-                <a:solidFill>
-                  <a:srgbClr val="0A0A0A"/>
-                </a:solidFill>
-                <a:latin typeface="Arial"/>
-                <a:ea typeface="Arial"/>
-                <a:cs typeface="Arial"/>
-              </a:rPr>
-              <a:t>Bruker/Wyko full-field height maps</a:t>
+              <a:t>Robust cross-track substrate detrending.</a:t>
             </a:r>
           </a:p>
           <a:p xmlns:a="http://schemas.openxmlformats.org/drawingml/2006/main">
@@ -8683,18 +8458,7 @@
                 <a:ea typeface="Arial"/>
                 <a:cs typeface="Arial"/>
               </a:rPr>
-              <a:t>–  </a:t>
-            </a:r>
-            <a:r>
-              <a:rPr sz="1200" b="0" i="0">
-                <a:solidFill>
-                  <a:srgbClr val="0A0A0A"/>
-                </a:solidFill>
-                <a:latin typeface="Arial"/>
-                <a:ea typeface="Arial"/>
-                <a:cs typeface="Arial"/>
-              </a:rPr>
-              <a:t>x, y in mm  ·  z resolved to nanometers</a:t>
+              <a:t>Connected 30%-height boundary crossings.</a:t>
             </a:r>
           </a:p>
           <a:p xmlns:a="http://schemas.openxmlformats.org/drawingml/2006/main">
@@ -8716,18 +8480,7 @@
                 <a:ea typeface="Arial"/>
                 <a:cs typeface="Arial"/>
               </a:rPr>
-              <a:t>–  </a:t>
-            </a:r>
-            <a:r>
-              <a:rPr sz="1200" b="0" i="0">
-                <a:solidFill>
-                  <a:srgbClr val="0A0A0A"/>
-                </a:solidFill>
-                <a:latin typeface="Arial"/>
-                <a:ea typeface="Arial"/>
-                <a:cs typeface="Arial"/>
-              </a:rPr>
-              <a:t>Defines the true deposited track height</a:t>
+              <a:t>0.40 mm physical smoothing window.</a:t>
             </a:r>
           </a:p>
           <a:p xmlns:a="http://schemas.openxmlformats.org/drawingml/2006/main">
@@ -8749,18 +8502,7 @@
                 <a:ea typeface="Arial"/>
                 <a:cs typeface="Arial"/>
               </a:rPr>
-              <a:t>–  </a:t>
-            </a:r>
-            <a:r>
-              <a:rPr sz="1200" b="0" i="0">
-                <a:solidFill>
-                  <a:srgbClr val="0A0A0A"/>
-                </a:solidFill>
-                <a:latin typeface="Arial"/>
-                <a:ea typeface="Arial"/>
-                <a:cs typeface="Arial"/>
-              </a:rPr>
-              <a:t>Lives in the SPACE domain</a:t>
+              <a:t>Missing acquisition gaps remain excluded.</a:t>
             </a:r>
           </a:p>
         </p:txBody>
@@ -8972,7 +8714,7 @@
                 <a:ea typeface="Arial"/>
                 <a:cs typeface="Arial"/>
               </a:rPr>
-              <a:t>Evaluation is cross-condition: grouped leave-one-track-out development on 8, 10, 14; Track 21 is scored after the pipeline is locked.</a:t>
+              <a:t>Every track is untouched once; model, feature family, preprocessing, and calibration are selected only inside the other three tracks.</a:t>
             </a:r>
           </a:p>
         </p:txBody>
@@ -9323,7 +9065,7 @@
                 <a:ea typeface="Georgia"/>
                 <a:cs typeface="Georgia"/>
               </a:rPr>
-              <a:t>From raw frames to leakage-safe local predictions</a:t>
+              <a:t>From raw frames to leakage-safe nested predictions</a:t>
             </a:r>
           </a:p>
         </p:txBody>
@@ -10012,7 +9754,7 @@
                 <a:ea typeface="Arial"/>
                 <a:cs typeface="Arial"/>
               </a:rPr>
-              <a:t>Select</a:t>
+              <a:t>Decompose</a:t>
             </a:r>
           </a:p>
         </p:txBody>
@@ -10065,7 +9807,7 @@
                 <a:ea typeface="Arial"/>
                 <a:cs typeface="Arial"/>
               </a:rPr>
-              <a:t>Compare fixed model families by grouped development CV</a:t>
+              <a:t>Separate condition baseline from local center/log-width residuals</a:t>
             </a:r>
           </a:p>
         </p:txBody>
@@ -10330,7 +10072,7 @@
                 <a:ea typeface="Arial"/>
                 <a:cs typeface="Arial"/>
               </a:rPr>
-              <a:t>Fit Tracks 8, 10, 14; evaluate width and boundaries on Track 21</a:t>
+              <a:t>Hold out each track once; select candidates inside the other three</a:t>
             </a:r>
           </a:p>
         </p:txBody>
@@ -10542,40 +10284,7 @@
                 <a:ea typeface="Arial"/>
                 <a:cs typeface="Arial"/>
               </a:rPr>
-              <a:t>Why this matters:  </a:t>
-            </a:r>
-            <a:r>
-              <a:rPr sz="1300" b="0" i="0">
-                <a:solidFill>
-                  <a:srgbClr val="0A0A0A"/>
-                </a:solidFill>
-                <a:latin typeface="Arial"/>
-                <a:ea typeface="Arial"/>
-                <a:cs typeface="Arial"/>
-              </a:rPr>
-              <a:t>every downstream feature is expressed in physical millimeter coordinates along the track — the model learns physics, not sensor artifacts.</a:t>
-            </a:r>
-          </a:p>
-          <a:p xmlns:a="http://schemas.openxmlformats.org/drawingml/2006/main">
-            <a:pPr algn="l">
-              <a:lnSpc>
-                <a:spcPct val="112000"/>
-              </a:lnSpc>
-              <a:spcAft>
-                <a:spcPts val="700"/>
-              </a:spcAft>
-              <a:buNone/>
-            </a:pPr>
-            <a:r>
-              <a:rPr sz="1050" b="0" i="1">
-                <a:solidFill>
-                  <a:srgbClr val="757575"/>
-                </a:solidFill>
-                <a:latin typeface="Arial"/>
-                <a:ea typeface="Arial"/>
-                <a:cs typeface="Arial"/>
-              </a:rPr>
-              <a:t>Generative AI (LLM) was used transparently as a collaborative coding tool: designing the leveling math, debugging dataframe alignment, and refining visualizations.</a:t>
+              <a:t>Audit rule: geometry, feature choice, model choice, and uncertainty calibration never see the current outer track. Generative AI assisted coding and layout; it did not alter measurements.</a:t>
             </a:r>
           </a:p>
         </p:txBody>
@@ -11191,40 +10900,7 @@
                 <a:ea typeface="Arial"/>
                 <a:cs typeface="Arial"/>
               </a:rPr>
-              <a:t>▪  </a:t>
-            </a:r>
-            <a:r>
-              <a:rPr sz="1300" b="0" i="0">
-                <a:solidFill>
-                  <a:srgbClr val="0A0A0A"/>
-                </a:solidFill>
-                <a:latin typeface="Arial"/>
-                <a:ea typeface="Arial"/>
-                <a:cs typeface="Arial"/>
-              </a:rPr>
-              <a:t>Raw profilometer scans carry significant </a:t>
-            </a:r>
-            <a:r>
-              <a:rPr sz="1300" b="1" i="0">
-                <a:solidFill>
-                  <a:srgbClr val="0A0A0A"/>
-                </a:solidFill>
-                <a:latin typeface="Arial"/>
-                <a:ea typeface="Arial"/>
-                <a:cs typeface="Arial"/>
-              </a:rPr>
-              <a:t>planar tilt</a:t>
-            </a:r>
-            <a:r>
-              <a:rPr sz="1300" b="0" i="0">
-                <a:solidFill>
-                  <a:srgbClr val="0A0A0A"/>
-                </a:solidFill>
-                <a:latin typeface="Arial"/>
-                <a:ea typeface="Arial"/>
-                <a:cs typeface="Arial"/>
-              </a:rPr>
-              <a:t>.</a:t>
+              <a:t>Interpolate missing y pixels only within each cross-section.</a:t>
             </a:r>
           </a:p>
           <a:p xmlns:a="http://schemas.openxmlformats.org/drawingml/2006/main">
@@ -11246,40 +10922,7 @@
                 <a:ea typeface="Arial"/>
                 <a:cs typeface="Arial"/>
               </a:rPr>
-              <a:t>▪  </a:t>
-            </a:r>
-            <a:r>
-              <a:rPr sz="1300" b="0" i="0">
-                <a:solidFill>
-                  <a:srgbClr val="0A0A0A"/>
-                </a:solidFill>
-                <a:latin typeface="Arial"/>
-                <a:ea typeface="Arial"/>
-                <a:cs typeface="Arial"/>
-              </a:rPr>
-              <a:t>We isolate the </a:t>
-            </a:r>
-            <a:r>
-              <a:rPr sz="1300" b="1" i="0">
-                <a:solidFill>
-                  <a:srgbClr val="0A0A0A"/>
-                </a:solidFill>
-                <a:latin typeface="Arial"/>
-                <a:ea typeface="Arial"/>
-                <a:cs typeface="Arial"/>
-              </a:rPr>
-              <a:t>bare substrate edges</a:t>
-            </a:r>
-            <a:r>
-              <a:rPr sz="1300" b="0" i="0">
-                <a:solidFill>
-                  <a:srgbClr val="0A0A0A"/>
-                </a:solidFill>
-                <a:latin typeface="Arial"/>
-                <a:ea typeface="Arial"/>
-                <a:cs typeface="Arial"/>
-              </a:rPr>
-              <a:t> (non-track regions) and fit a 2D plane via linear regression.</a:t>
+              <a:t>Fit substrate slope outside the bead shoulders.</a:t>
             </a:r>
           </a:p>
           <a:p xmlns:a="http://schemas.openxmlformats.org/drawingml/2006/main">
@@ -11301,40 +10944,29 @@
                 <a:ea typeface="Arial"/>
                 <a:cs typeface="Arial"/>
               </a:rPr>
-              <a:t>▪  </a:t>
-            </a:r>
+              <a:t>Locate connected 30%-of-peak crossings around the central maximum.</a:t>
+            </a:r>
+          </a:p>
+          <a:p xmlns:a="http://schemas.openxmlformats.org/drawingml/2006/main">
+            <a:pPr algn="l">
+              <a:lnSpc>
+                <a:spcPct val="112000"/>
+              </a:lnSpc>
+              <a:spcAft>
+                <a:spcPts val="1100"/>
+              </a:spcAft>
+              <a:buNone/>
+            </a:pPr>
             <a:r>
               <a:rPr sz="1300" b="0" i="0">
                 <a:solidFill>
-                  <a:srgbClr val="0A0A0A"/>
+                  <a:srgbClr val="051C2C"/>
                 </a:solidFill>
                 <a:latin typeface="Arial"/>
                 <a:ea typeface="Arial"/>
                 <a:cs typeface="Arial"/>
               </a:rPr>
-              <a:t>Subtracting the fitted plane levels the substrate to ≈ 0, exposing the </a:t>
-            </a:r>
-            <a:r>
-              <a:rPr sz="1300" b="1" i="0">
-                <a:solidFill>
-                  <a:srgbClr val="0A0A0A"/>
-                </a:solidFill>
-                <a:latin typeface="Arial"/>
-                <a:ea typeface="Arial"/>
-                <a:cs typeface="Arial"/>
-              </a:rPr>
-              <a:t>true deposited height</a:t>
-            </a:r>
-            <a:r>
-              <a:rPr sz="1300" b="0" i="0">
-                <a:solidFill>
-                  <a:srgbClr val="0A0A0A"/>
-                </a:solidFill>
-                <a:latin typeface="Arial"/>
-                <a:ea typeface="Arial"/>
-                <a:cs typeface="Arial"/>
-              </a:rPr>
-              <a:t> — our ground truth.</a:t>
+              <a:t>Smooth left and right boundaries over 0.40 mm.</a:t>
             </a:r>
           </a:p>
         </p:txBody>
@@ -11546,40 +11178,7 @@
                 <a:ea typeface="Arial"/>
                 <a:cs typeface="Arial"/>
               </a:rPr>
-              <a:t>▪  </a:t>
-            </a:r>
-            <a:r>
-              <a:rPr sz="1300" b="0" i="0">
-                <a:solidFill>
-                  <a:srgbClr val="0A0A0A"/>
-                </a:solidFill>
-                <a:latin typeface="Arial"/>
-                <a:ea typeface="Arial"/>
-                <a:cs typeface="Arial"/>
-              </a:rPr>
-              <a:t>Melt pool </a:t>
-            </a:r>
-            <a:r>
-              <a:rPr sz="1300" b="1" i="0">
-                <a:solidFill>
-                  <a:srgbClr val="0A0A0A"/>
-                </a:solidFill>
-                <a:latin typeface="Arial"/>
-                <a:ea typeface="Arial"/>
-                <a:cs typeface="Arial"/>
-              </a:rPr>
-              <a:t>length, width &amp; area</a:t>
-            </a:r>
-            <a:r>
-              <a:rPr sz="1300" b="0" i="0">
-                <a:solidFill>
-                  <a:srgbClr val="0A0A0A"/>
-                </a:solidFill>
-                <a:latin typeface="Arial"/>
-                <a:ea typeface="Arial"/>
-                <a:cs typeface="Arial"/>
-              </a:rPr>
-              <a:t> extracted from each thermal frame by intensity thresholding (value = 2000).</a:t>
+              <a:t>Detect laser shutoff; retain the prior 400 active frames.</a:t>
             </a:r>
           </a:p>
           <a:p xmlns:a="http://schemas.openxmlformats.org/drawingml/2006/main">
@@ -11601,40 +11200,7 @@
                 <a:ea typeface="Arial"/>
                 <a:cs typeface="Arial"/>
               </a:rPr>
-              <a:t>▪  </a:t>
-            </a:r>
-            <a:r>
-              <a:rPr sz="1300" b="0" i="0">
-                <a:solidFill>
-                  <a:srgbClr val="0A0A0A"/>
-                </a:solidFill>
-                <a:latin typeface="Arial"/>
-                <a:ea typeface="Arial"/>
-                <a:cs typeface="Arial"/>
-              </a:rPr>
-              <a:t>Constant scan speed (10 mm/s @ 50 fps) → each frame advances </a:t>
-            </a:r>
-            <a:r>
-              <a:rPr sz="1300" b="1" i="0">
-                <a:solidFill>
-                  <a:srgbClr val="0A0A0A"/>
-                </a:solidFill>
-                <a:latin typeface="Arial"/>
-                <a:ea typeface="Arial"/>
-                <a:cs typeface="Arial"/>
-              </a:rPr>
-              <a:t>0.2 mm</a:t>
-            </a:r>
-            <a:r>
-              <a:rPr sz="1300" b="0" i="0">
-                <a:solidFill>
-                  <a:srgbClr val="0A0A0A"/>
-                </a:solidFill>
-                <a:latin typeface="Arial"/>
-                <a:ea typeface="Arial"/>
-                <a:cs typeface="Arial"/>
-              </a:rPr>
-              <a:t> along the track.</a:t>
+              <a:t>Extract hot components above a fixed 1500 K threshold.</a:t>
             </a:r>
           </a:p>
           <a:p xmlns:a="http://schemas.openxmlformats.org/drawingml/2006/main">
@@ -11656,40 +11222,29 @@
                 <a:ea typeface="Arial"/>
                 <a:cs typeface="Arial"/>
               </a:rPr>
-              <a:t>▪  </a:t>
-            </a:r>
+              <a:t>Convert time to x at 10 mm/s and 50 fps.</a:t>
+            </a:r>
+          </a:p>
+          <a:p xmlns:a="http://schemas.openxmlformats.org/drawingml/2006/main">
+            <a:pPr algn="l">
+              <a:lnSpc>
+                <a:spcPct val="112000"/>
+              </a:lnSpc>
+              <a:spcAft>
+                <a:spcPts val="1100"/>
+              </a:spcAft>
+              <a:buNone/>
+            </a:pPr>
             <a:r>
               <a:rPr sz="1300" b="0" i="0">
                 <a:solidFill>
-                  <a:srgbClr val="0A0A0A"/>
+                  <a:srgbClr val="051C2C"/>
                 </a:solidFill>
                 <a:latin typeface="Arial"/>
                 <a:ea typeface="Arial"/>
                 <a:cs typeface="Arial"/>
               </a:rPr>
-              <a:t>Linear interpolation maps all 400 frames onto the </a:t>
-            </a:r>
-            <a:r>
-              <a:rPr sz="1300" b="1" i="0">
-                <a:solidFill>
-                  <a:srgbClr val="0A0A0A"/>
-                </a:solidFill>
-                <a:latin typeface="Arial"/>
-                <a:ea typeface="Arial"/>
-                <a:cs typeface="Arial"/>
-              </a:rPr>
-              <a:t>20–100 mm coordinates</a:t>
-            </a:r>
-            <a:r>
-              <a:rPr sz="1300" b="0" i="0">
-                <a:solidFill>
-                  <a:srgbClr val="0A0A0A"/>
-                </a:solidFill>
-                <a:latin typeface="Arial"/>
-                <a:ea typeface="Arial"/>
-                <a:cs typeface="Arial"/>
-              </a:rPr>
-              <a:t> of the leveled height profile.</a:t>
+              <a:t>Reject frames more than 0.10 mm from valid profilometry.</a:t>
             </a:r>
           </a:p>
         </p:txBody>
@@ -12093,7 +11648,7 @@
                 <a:ea typeface="Georgia"/>
                 <a:cs typeface="Georgia"/>
               </a:rPr>
-              <a:t>Model selection: rich thermal history wins without SEM</a:t>
+              <a:t>Separate condition width from local variation</a:t>
             </a:r>
           </a:p>
         </p:txBody>
@@ -12252,7 +11807,7 @@
                 <a:ea typeface="Arial"/>
                 <a:cs typeface="Arial"/>
               </a:rPr>
-              <a:t>THERMAL DESCRIPTORS</a:t>
+              <a:t>CAUSAL MULTISCALE HISTORY</a:t>
             </a:r>
           </a:p>
         </p:txBody>
@@ -12305,7 +11860,7 @@
                 <a:ea typeface="Georgia"/>
                 <a:cs typeface="Georgia"/>
               </a:rPr>
-              <a:t>Short histories describe pool shape, energy, and change</a:t>
+              <a:t>Describe the pool now, then summarize how it arrived</a:t>
             </a:r>
           </a:p>
         </p:txBody>
@@ -12358,29 +11913,7 @@
                 <a:ea typeface="Arial"/>
                 <a:cs typeface="Arial"/>
               </a:rPr>
-              <a:t>▪  </a:t>
-            </a:r>
-            <a:r>
-              <a:rPr sz="1300" b="1" i="0">
-                <a:solidFill>
-                  <a:srgbClr val="0A0A0A"/>
-                </a:solidFill>
-                <a:latin typeface="Arial"/>
-                <a:ea typeface="Arial"/>
-                <a:cs typeface="Arial"/>
-              </a:rPr>
-              <a:t>Rolling averages</a:t>
-            </a:r>
-            <a:r>
-              <a:rPr sz="1300" b="0" i="0">
-                <a:solidFill>
-                  <a:srgbClr val="0A0A0A"/>
-                </a:solidFill>
-                <a:latin typeface="Arial"/>
-                <a:ea typeface="Arial"/>
-                <a:cs typeface="Arial"/>
-              </a:rPr>
-              <a:t> of melt pool dimensions over 5- and 10-frame windows.</a:t>
+              <a:t>Pool axes, temperature, mass, gradients, and asymmetry.</a:t>
             </a:r>
           </a:p>
           <a:p xmlns:a="http://schemas.openxmlformats.org/drawingml/2006/main">
@@ -12402,40 +11935,7 @@
                 <a:ea typeface="Arial"/>
                 <a:cs typeface="Arial"/>
               </a:rPr>
-              <a:t>▪  </a:t>
-            </a:r>
-            <a:r>
-              <a:rPr sz="1300" b="0" i="0">
-                <a:solidFill>
-                  <a:srgbClr val="0A0A0A"/>
-                </a:solidFill>
-                <a:latin typeface="Arial"/>
-                <a:ea typeface="Arial"/>
-                <a:cs typeface="Arial"/>
-              </a:rPr>
-              <a:t>These act as a proxy for </a:t>
-            </a:r>
-            <a:r>
-              <a:rPr sz="1300" b="1" i="0">
-                <a:solidFill>
-                  <a:srgbClr val="0A0A0A"/>
-                </a:solidFill>
-                <a:latin typeface="Arial"/>
-                <a:ea typeface="Arial"/>
-                <a:cs typeface="Arial"/>
-              </a:rPr>
-              <a:t>heat accumulation and cooling rate</a:t>
-            </a:r>
-            <a:r>
-              <a:rPr sz="1300" b="0" i="0">
-                <a:solidFill>
-                  <a:srgbClr val="0A0A0A"/>
-                </a:solidFill>
-                <a:latin typeface="Arial"/>
-                <a:ea typeface="Arial"/>
-                <a:cs typeface="Arial"/>
-              </a:rPr>
-              <a:t> at each point along the path.</a:t>
+              <a:t>Cooling-tail decay, centroid velocity, and shape change.</a:t>
             </a:r>
           </a:p>
           <a:p xmlns:a="http://schemas.openxmlformats.org/drawingml/2006/main">
@@ -12457,18 +11957,29 @@
                 <a:ea typeface="Arial"/>
                 <a:cs typeface="Arial"/>
               </a:rPr>
-              <a:t>▪  </a:t>
-            </a:r>
+              <a:t>5-, 10-, and 20-frame slopes, persistence, and changes.</a:t>
+            </a:r>
+          </a:p>
+          <a:p xmlns:a="http://schemas.openxmlformats.org/drawingml/2006/main">
+            <a:pPr algn="l">
+              <a:lnSpc>
+                <a:spcPct val="112000"/>
+              </a:lnSpc>
+              <a:spcAft>
+                <a:spcPts val="1100"/>
+              </a:spcAft>
+              <a:buNone/>
+            </a:pPr>
             <a:r>
               <a:rPr sz="1300" b="0" i="0">
                 <a:solidFill>
-                  <a:srgbClr val="0A0A0A"/>
+                  <a:srgbClr val="051C2C"/>
                 </a:solidFill>
                 <a:latin typeface="Arial"/>
                 <a:ea typeface="Arial"/>
                 <a:cs typeface="Arial"/>
               </a:rPr>
-              <a:t>Captures the longitudinal variation a single frame cannot see.</a:t>
+              <a:t>Robust local normalization isolates within-track departures.</a:t>
             </a:r>
           </a:p>
         </p:txBody>
@@ -12574,7 +12085,7 @@
                 <a:ea typeface="Arial"/>
                 <a:cs typeface="Arial"/>
               </a:rPr>
-              <a:t>GROUPED MODEL SELECTION</a:t>
+              <a:t>CONSTRAINED NESTED MODEL</a:t>
             </a:r>
           </a:p>
         </p:txBody>
@@ -12627,7 +12138,7 @@
                 <a:ea typeface="Georgia"/>
                 <a:cs typeface="Georgia"/>
               </a:rPr>
-              <a:t>Three development tracks choose the model without Track 21</a:t>
+              <a:t>Predict a track baseline, then local residuals</a:t>
             </a:r>
           </a:p>
         </p:txBody>
@@ -12680,40 +12191,7 @@
                 <a:ea typeface="Arial"/>
                 <a:cs typeface="Arial"/>
               </a:rPr>
-              <a:t>▪  </a:t>
-            </a:r>
-            <a:r>
-              <a:rPr sz="1300" b="0" i="0">
-                <a:solidFill>
-                  <a:srgbClr val="0A0A0A"/>
-                </a:solidFill>
-                <a:latin typeface="Arial"/>
-                <a:ea typeface="Arial"/>
-                <a:cs typeface="Arial"/>
-              </a:rPr>
-              <a:t>Localized </a:t>
-            </a:r>
-            <a:r>
-              <a:rPr sz="1300" b="1" i="0">
-                <a:solidFill>
-                  <a:srgbClr val="0A0A0A"/>
-                </a:solidFill>
-                <a:latin typeface="Arial"/>
-                <a:ea typeface="Arial"/>
-                <a:cs typeface="Arial"/>
-              </a:rPr>
-              <a:t>SEM intensity and SEM roughness</a:t>
-            </a:r>
-            <a:r>
-              <a:rPr sz="1300" b="0" i="0">
-                <a:solidFill>
-                  <a:srgbClr val="0A0A0A"/>
-                </a:solidFill>
-                <a:latin typeface="Arial"/>
-                <a:ea typeface="Arial"/>
-                <a:cs typeface="Arial"/>
-              </a:rPr>
-              <a:t> matrices extracted from masked SEM imagery.</a:t>
+              <a:t>Track summaries predict baseline center and log-width.</a:t>
             </a:r>
           </a:p>
           <a:p xmlns:a="http://schemas.openxmlformats.org/drawingml/2006/main">
@@ -12735,40 +12213,7 @@
                 <a:ea typeface="Arial"/>
                 <a:cs typeface="Arial"/>
               </a:rPr>
-              <a:t>▪  </a:t>
-            </a:r>
-            <a:r>
-              <a:rPr sz="1300" b="0" i="0">
-                <a:solidFill>
-                  <a:srgbClr val="0A0A0A"/>
-                </a:solidFill>
-                <a:latin typeface="Arial"/>
-                <a:ea typeface="Arial"/>
-                <a:cs typeface="Arial"/>
-              </a:rPr>
-              <a:t>Quantifies the </a:t>
-            </a:r>
-            <a:r>
-              <a:rPr sz="1300" b="1" i="0">
-                <a:solidFill>
-                  <a:srgbClr val="0A0A0A"/>
-                </a:solidFill>
-                <a:latin typeface="Arial"/>
-                <a:ea typeface="Arial"/>
-                <a:cs typeface="Arial"/>
-              </a:rPr>
-              <a:t>topographical foundation</a:t>
-            </a:r>
-            <a:r>
-              <a:rPr sz="1300" b="0" i="0">
-                <a:solidFill>
-                  <a:srgbClr val="0A0A0A"/>
-                </a:solidFill>
-                <a:latin typeface="Arial"/>
-                <a:ea typeface="Arial"/>
-                <a:cs typeface="Arial"/>
-              </a:rPr>
-              <a:t> prior to deposition — gouges, texture, reflectivity.</a:t>
+              <a:t>Local history jointly predicts center and log-width residuals.</a:t>
             </a:r>
           </a:p>
           <a:p xmlns:a="http://schemas.openxmlformats.org/drawingml/2006/main">
@@ -12790,18 +12235,29 @@
                 <a:ea typeface="Arial"/>
                 <a:cs typeface="Arial"/>
               </a:rPr>
-              <a:t>▪  </a:t>
-            </a:r>
+              <a:t>exp(log-width) keeps width positive; boundaries stay ordered.</a:t>
+            </a:r>
+          </a:p>
+          <a:p xmlns:a="http://schemas.openxmlformats.org/drawingml/2006/main">
+            <a:pPr algn="l">
+              <a:lnSpc>
+                <a:spcPct val="112000"/>
+              </a:lnSpc>
+              <a:spcAft>
+                <a:spcPts val="1100"/>
+              </a:spcAft>
+              <a:buNone/>
+            </a:pPr>
             <a:r>
               <a:rPr sz="1300" b="0" i="0">
                 <a:solidFill>
-                  <a:srgbClr val="0A0A0A"/>
+                  <a:srgbClr val="051C2C"/>
                 </a:solidFill>
                 <a:latin typeface="Arial"/>
                 <a:ea typeface="Arial"/>
                 <a:cs typeface="Arial"/>
               </a:rPr>
-              <a:t>Track region masked out to strictly avoid output leakage.</a:t>
+              <a:t>Nested folds choose Ridge, elastic net, PLS, spline, or GP.</a:t>
             </a:r>
           </a:p>
         </p:txBody>
@@ -13205,7 +12661,7 @@
                 <a:ea typeface="Georgia"/>
                 <a:cs typeface="Georgia"/>
               </a:rPr>
-              <a:t>Audited model reduces held-out Track 21 MAE by 12.3%</a:t>
+              <a:t>Four-track MAE falls 13.1% while boundaries improve</a:t>
             </a:r>
           </a:p>
         </p:txBody>
@@ -13311,7 +12767,7 @@
                 <a:ea typeface="Arial"/>
                 <a:cs typeface="Arial"/>
               </a:rPr>
-              <a:t>EXHIBIT 1 - HELD-OUT LOCAL TRACK WIDTH</a:t>
+              <a:t>EXHIBIT 1 - FOUR UNTOUCHED OUTER TRACKS</a:t>
             </a:r>
           </a:p>
         </p:txBody>
@@ -13380,7 +12836,7 @@
           <p:nvPr/>
         </p:nvPicPr>
         <p:blipFill>
-          <a:blip xmlns:r="http://schemas.openxmlformats.org/officeDocument/2006/relationships" xmlns:a="http://schemas.openxmlformats.org/drawingml/2006/main" r:embed="R07e59468898341eb"/>
+          <a:blip xmlns:r="http://schemas.openxmlformats.org/officeDocument/2006/relationships" xmlns:a="http://schemas.openxmlformats.org/drawingml/2006/main" r:embed="R7436dbe109274010"/>
           <a:stretch xmlns:a="http://schemas.openxmlformats.org/drawingml/2006/main">
             <a:fillRect l="0" t="0" r="0" b="0"/>
           </a:stretch>
@@ -13443,7 +12899,7 @@
                 <a:ea typeface="Georgia"/>
                 <a:cs typeface="Georgia"/>
               </a:rPr>
-              <a:t>139 µm</a:t>
+              <a:t>163 µm</a:t>
             </a:r>
           </a:p>
           <a:p xmlns:a="http://schemas.openxmlformats.org/drawingml/2006/main">
@@ -13465,7 +12921,7 @@
                 <a:ea typeface="Arial"/>
                 <a:cs typeface="Arial"/>
               </a:rPr>
-              <a:t>Held-out MAE</a:t>
+              <a:t>Track-balanced MAE</a:t>
             </a:r>
           </a:p>
         </p:txBody>
@@ -13518,7 +12974,7 @@
                 <a:ea typeface="Georgia"/>
                 <a:cs typeface="Georgia"/>
               </a:rPr>
-              <a:t>12.3% lower</a:t>
+              <a:t>13.1% lower</a:t>
             </a:r>
           </a:p>
           <a:p xmlns:a="http://schemas.openxmlformats.org/drawingml/2006/main">
@@ -13540,7 +12996,7 @@
                 <a:ea typeface="Arial"/>
                 <a:cs typeface="Arial"/>
               </a:rPr>
-              <a:t>vs. notebook baseline</a:t>
+              <a:t>vs. direct Ridge</a:t>
             </a:r>
           </a:p>
         </p:txBody>
@@ -13699,7 +13155,7 @@
                 <a:ea typeface="Arial"/>
                 <a:cs typeface="Arial"/>
               </a:rPr>
-              <a:t>Baseline MAE: 0.159 mm; audited Ridge MAE: 0.139 mm.</a:t>
+              <a:t>Track-balanced width MAE: 0.187 → 0.163 mm.</a:t>
             </a:r>
           </a:p>
           <a:p xmlns:a="http://schemas.openxmlformats.org/drawingml/2006/main">
@@ -13721,7 +13177,7 @@
                 <a:ea typeface="Arial"/>
                 <a:cs typeface="Arial"/>
               </a:rPr>
-              <a:t>RMSE improves from 0.187 mm to 0.167 mm.</a:t>
+              <a:t>Worst-track MAE: 0.308 → 0.219 mm.</a:t>
             </a:r>
           </a:p>
           <a:p xmlns:a="http://schemas.openxmlformats.org/drawingml/2006/main">
@@ -13743,7 +13199,7 @@
                 <a:ea typeface="Arial"/>
                 <a:cs typeface="Arial"/>
               </a:rPr>
-              <a:t>Development grouped-CV MAE improves from 0.137 mm to 0.088 mm.</a:t>
+              <a:t>Mean boundary MAE: 0.180 → 0.148 mm.</a:t>
             </a:r>
           </a:p>
           <a:p xmlns:a="http://schemas.openxmlformats.org/drawingml/2006/main">
@@ -13765,7 +13221,7 @@
                 <a:ea typeface="Arial"/>
                 <a:cs typeface="Arial"/>
               </a:rPr>
-              <a:t>Point prediction improves, but held-out R² remains negative (-0.58).</a:t>
+              <a:t>Residual correlation: 0.055 → 0.124.</a:t>
             </a:r>
           </a:p>
         </p:txBody>
@@ -14116,7 +13572,7 @@
                 <a:ea typeface="Georgia"/>
                 <a:cs typeface="Georgia"/>
               </a:rPr>
-              <a:t>Thermal history generalizes better than masked SEM</a:t>
+              <a:t>Local scaling recovers variation and sharpens uncertainty</a:t>
             </a:r>
           </a:p>
         </p:txBody>
@@ -14222,7 +13678,7 @@
                 <a:ea typeface="Arial"/>
                 <a:cs typeface="Arial"/>
               </a:rPr>
-              <a:t>EXHIBIT 2 - VALIDATION PERMUTATION IMPORTANCE</a:t>
+              <a:t>EXHIBIT 2 - BEFORE / AFTER SCORECARD</a:t>
             </a:r>
           </a:p>
         </p:txBody>
@@ -14291,7 +13747,7 @@
           <p:nvPr/>
         </p:nvPicPr>
         <p:blipFill>
-          <a:blip xmlns:r="http://schemas.openxmlformats.org/officeDocument/2006/relationships" xmlns:a="http://schemas.openxmlformats.org/drawingml/2006/main" r:embed="R8769a06ae3154354"/>
+          <a:blip xmlns:r="http://schemas.openxmlformats.org/officeDocument/2006/relationships" xmlns:a="http://schemas.openxmlformats.org/drawingml/2006/main" r:embed="Rc4f6e0b2f37f4a50"/>
           <a:stretch xmlns:a="http://schemas.openxmlformats.org/drawingml/2006/main">
             <a:fillRect l="0" t="0" r="0" b="0"/>
           </a:stretch>
@@ -14460,7 +13916,7 @@
                 <a:ea typeface="Arial"/>
                 <a:cs typeface="Arial"/>
               </a:rPr>
-              <a:t>WHAT THE AUDIT FOUND</a:t>
+              <a:t>WHAT CHANGED</a:t>
             </a:r>
           </a:p>
         </p:txBody>
@@ -14513,7 +13969,7 @@
                 <a:ea typeface="Georgia"/>
                 <a:cs typeface="Georgia"/>
               </a:rPr>
-              <a:t>Hot-region temperature and thermal mass lead</a:t>
+              <a:t>Condition baseline + local residual wins</a:t>
             </a:r>
           </a:p>
         </p:txBody>
@@ -14566,18 +14022,7 @@
                 <a:ea typeface="Arial"/>
                 <a:cs typeface="Arial"/>
               </a:rPr>
-              <a:t>1.  </a:t>
-            </a:r>
-            <a:r>
-              <a:rPr sz="1250" b="0" i="0">
-                <a:solidFill>
-                  <a:srgbClr val="0A0A0A"/>
-                </a:solidFill>
-                <a:latin typeface="Arial"/>
-                <a:ea typeface="Arial"/>
-                <a:cs typeface="Arial"/>
-              </a:rPr>
-              <a:t>Substrate texture governs heat dissipation and liquid metal flow.</a:t>
+              <a:t>1. Predicted variation grows from 21% to 36% of measured scale.</a:t>
             </a:r>
           </a:p>
           <a:p xmlns:a="http://schemas.openxmlformats.org/drawingml/2006/main">
@@ -14599,18 +14044,7 @@
                 <a:ea typeface="Arial"/>
                 <a:cs typeface="Arial"/>
               </a:rPr>
-              <a:t>2.  </a:t>
-            </a:r>
-            <a:r>
-              <a:rPr sz="1250" b="0" i="0">
-                <a:solidFill>
-                  <a:srgbClr val="0A0A0A"/>
-                </a:solidFill>
-                <a:latin typeface="Arial"/>
-                <a:ea typeface="Arial"/>
-                <a:cs typeface="Arial"/>
-              </a:rPr>
-              <a:t>Thermal history (rolling melt pool areas) ranks next — heat buildup matters.</a:t>
+              <a:t>2. Conditional intervals cover 91.4% at 0.738 mm mean width.</a:t>
             </a:r>
           </a:p>
           <a:p xmlns:a="http://schemas.openxmlformats.org/drawingml/2006/main">
@@ -14632,18 +14066,29 @@
                 <a:ea typeface="Arial"/>
                 <a:cs typeface="Arial"/>
               </a:rPr>
-              <a:t>3.  </a:t>
-            </a:r>
-            <a:r>
-              <a:rPr sz="1250" b="0" i="0">
-                <a:solidFill>
-                  <a:srgbClr val="0A0A0A"/>
+              <a:t>3. Global intervals cover 94.2% but are wider at 0.824 mm.</a:t>
+            </a:r>
+          </a:p>
+          <a:p xmlns:a="http://schemas.openxmlformats.org/drawingml/2006/main">
+            <a:pPr algn="l">
+              <a:lnSpc>
+                <a:spcPct val="115000"/>
+              </a:lnSpc>
+              <a:spcAft>
+                <a:spcPts val="900"/>
+              </a:spcAft>
+              <a:buNone/>
+            </a:pPr>
+            <a:r>
+              <a:rPr sz="1250" b="1" i="0">
+                <a:solidFill>
+                  <a:srgbClr val="2251FF"/>
                 </a:solidFill>
                 <a:latin typeface="Arial"/>
                 <a:ea typeface="Arial"/>
                 <a:cs typeface="Arial"/>
               </a:rPr>
-              <a:t>Instantaneous melt pool size alone is the weakest signal.</a:t>
+              <a:t>4. Width expands from 0.610 mm easy to 0.912 mm hard.</a:t>
             </a:r>
           </a:p>
         </p:txBody>
@@ -14994,7 +14439,7 @@
                 <a:ea typeface="Georgia"/>
                 <a:cs typeface="Georgia"/>
               </a:rPr>
-              <a:t>Improved, but not reliable enough for closed-loop control</a:t>
+              <a:t>Improved, but not ready for closed-loop control</a:t>
             </a:r>
           </a:p>
         </p:txBody>
@@ -15100,7 +14545,7 @@
                 <a:ea typeface="Arial"/>
                 <a:cs typeface="Arial"/>
               </a:rPr>
-              <a:t>Held-out R² is -0.58: the condition shift still dominates local fit.</a:t>
+              <a:t>Track-balanced R² is -0.34; local predictions still miss structure.</a:t>
             </a:r>
           </a:p>
           <a:p xmlns:a="http://schemas.openxmlformats.org/drawingml/2006/main">
@@ -15122,7 +14567,7 @@
                 <a:ea typeface="Arial"/>
                 <a:cs typeface="Arial"/>
               </a:rPr>
-              <a:t>Nominal 90% intervals cover 76.5% of Track 21 points.</a:t>
+              <a:t>Four tracks cannot establish stability across plates or recipes.</a:t>
             </a:r>
           </a:p>
           <a:p xmlns:a="http://schemas.openxmlformats.org/drawingml/2006/main">
@@ -15144,7 +14589,7 @@
                 <a:ea typeface="Arial"/>
                 <a:cs typeface="Arial"/>
               </a:rPr>
-              <a:t>Track 21 profilometry is incomplete; only valid regions are scored.</a:t>
+              <a:t>Nested Track 21 MAE is 0.219 mm; the prior 0.139 mm is historical only.</a:t>
             </a:r>
           </a:p>
           <a:p xmlns:a="http://schemas.openxmlformats.org/drawingml/2006/main">
@@ -15166,7 +14611,7 @@
                 <a:ea typeface="Arial"/>
                 <a:cs typeface="Arial"/>
               </a:rPr>
-              <a:t>Mean left/right boundary MAE is 0.174 mm.</a:t>
+              <a:t>Post-process SEM is selected in zero folds.</a:t>
             </a:r>
           </a:p>
           <a:p xmlns:a="http://schemas.openxmlformats.org/drawingml/2006/main">
@@ -15188,7 +14633,7 @@
                 <a:ea typeface="Arial"/>
                 <a:cs typeface="Arial"/>
               </a:rPr>
-              <a:t>Four conditions cannot cleanly separate substrate from process.</a:t>
+              <a:t>No causal substrate claim is supported.</a:t>
             </a:r>
           </a:p>
         </p:txBody>

</xml_diff>

<commit_message>
feat: finalize leakage-audited competition submission
Promote the completed-sequence offline hierarchy, retain a causal ablation, and regenerate rubric-compliant report, notebook, deck, and package materials.

Co-Authored-By: Codex Opus 4.7 <noreply@anthropic.com>
</commit_message>
<xml_diff>
--- a/deliverables/presentation/FMRG_Final_Submission_Audited.pptx
+++ b/deliverables/presentation/FMRG_Final_Submission_Audited.pptx
@@ -2,22 +2,22 @@
 <file path=ppt/presentation.xml><?xml version="1.0" encoding="utf-8"?>
 <p:presentation xmlns:p="http://schemas.openxmlformats.org/presentationml/2006/main">
   <p:sldMasterIdLst>
-    <p:sldMasterId xmlns:r="http://schemas.openxmlformats.org/officeDocument/2006/relationships" id="2147483648" r:id="R48aefe7c3d8f4e31"/>
+    <p:sldMasterId xmlns:r="http://schemas.openxmlformats.org/officeDocument/2006/relationships" id="2147483648" r:id="R80e315ac38c74732"/>
   </p:sldMasterIdLst>
   <p:notesMasterIdLst>
-    <p:notesMasterId xmlns:r="http://schemas.openxmlformats.org/officeDocument/2006/relationships" r:id="R2daeaec5699d4038"/>
+    <p:notesMasterId xmlns:r="http://schemas.openxmlformats.org/officeDocument/2006/relationships" r:id="R6024b99a80c04a03"/>
   </p:notesMasterIdLst>
   <p:sldIdLst>
-    <p:sldId xmlns:r="http://schemas.openxmlformats.org/officeDocument/2006/relationships" id="256" r:id="R3e212b8c2c2442c5"/>
-    <p:sldId xmlns:r="http://schemas.openxmlformats.org/officeDocument/2006/relationships" id="257" r:id="R5b491bdc725443bf"/>
-    <p:sldId xmlns:r="http://schemas.openxmlformats.org/officeDocument/2006/relationships" id="258" r:id="R5e55f3ea31264b3c"/>
-    <p:sldId xmlns:r="http://schemas.openxmlformats.org/officeDocument/2006/relationships" id="259" r:id="Rf982cd6daf2d4857"/>
-    <p:sldId xmlns:r="http://schemas.openxmlformats.org/officeDocument/2006/relationships" id="260" r:id="R1ca719f633da4bff"/>
-    <p:sldId xmlns:r="http://schemas.openxmlformats.org/officeDocument/2006/relationships" id="261" r:id="R448c7d18d07c4f67"/>
-    <p:sldId xmlns:r="http://schemas.openxmlformats.org/officeDocument/2006/relationships" id="262" r:id="Reaceccc462674caf"/>
-    <p:sldId xmlns:r="http://schemas.openxmlformats.org/officeDocument/2006/relationships" id="263" r:id="R442fd858f561497f"/>
-    <p:sldId xmlns:r="http://schemas.openxmlformats.org/officeDocument/2006/relationships" id="264" r:id="R8e63aad46c2248cb"/>
-    <p:sldId xmlns:r="http://schemas.openxmlformats.org/officeDocument/2006/relationships" id="265" r:id="R93c326c4ca744e67"/>
+    <p:sldId xmlns:r="http://schemas.openxmlformats.org/officeDocument/2006/relationships" id="256" r:id="Rb40d7147949144d4"/>
+    <p:sldId xmlns:r="http://schemas.openxmlformats.org/officeDocument/2006/relationships" id="257" r:id="R7677a9ce10634e21"/>
+    <p:sldId xmlns:r="http://schemas.openxmlformats.org/officeDocument/2006/relationships" id="258" r:id="R71496d15c33a4be1"/>
+    <p:sldId xmlns:r="http://schemas.openxmlformats.org/officeDocument/2006/relationships" id="259" r:id="Rd6d646222a354756"/>
+    <p:sldId xmlns:r="http://schemas.openxmlformats.org/officeDocument/2006/relationships" id="260" r:id="R3b55d5b1b5584aa1"/>
+    <p:sldId xmlns:r="http://schemas.openxmlformats.org/officeDocument/2006/relationships" id="261" r:id="R1dc2c6f9f9af4f28"/>
+    <p:sldId xmlns:r="http://schemas.openxmlformats.org/officeDocument/2006/relationships" id="262" r:id="R3b20daf4dbcd49fa"/>
+    <p:sldId xmlns:r="http://schemas.openxmlformats.org/officeDocument/2006/relationships" id="263" r:id="R921d78e60ccf41a8"/>
+    <p:sldId xmlns:r="http://schemas.openxmlformats.org/officeDocument/2006/relationships" id="264" r:id="Rcd4974ceb65a43f7"/>
+    <p:sldId xmlns:r="http://schemas.openxmlformats.org/officeDocument/2006/relationships" id="265" r:id="R78189b7ce49843ca"/>
   </p:sldIdLst>
   <p:sldSz cx="12191695" cy="6858000"/>
   <p:notesSz cx="6858000" cy="9144000"/>
@@ -579,7 +579,7 @@
           <a:lstStyle xmlns:a="http://schemas.openxmlformats.org/drawingml/2006/main"/>
           <a:p xmlns:a="http://schemas.openxmlformats.org/drawingml/2006/main">
             <a:r>
-              <a:t>Close: separating the condition shift from local variation is the main transferable modeling insight.</a:t>
+              <a:t>Close: separating the condition shift from local variation is the main transferable modeling insight. Generative AI assisted code review, testing, debugging, and layout; team members reviewed the outputs, and AI did not create or alter measurements.</a:t>
             </a:r>
           </a:p>
           <a:p xmlns:a="http://schemas.openxmlformats.org/drawingml/2006/main">
@@ -1104,7 +1104,7 @@
           <a:lstStyle xmlns:a="http://schemas.openxmlformats.org/drawingml/2006/main"/>
           <a:p xmlns:a="http://schemas.openxmlformats.org/drawingml/2006/main">
             <a:r>
-              <a:t>Modeling: causal multiscale history predicts local residuals while track summaries predict condition baselines.</a:t>
+              <a:t>Modeling: completed-sequence summaries predict condition baselines; frame history predicts local residuals. The primary mode is offline.</a:t>
             </a:r>
           </a:p>
           <a:p xmlns:a="http://schemas.openxmlformats.org/drawingml/2006/main">
@@ -1209,7 +1209,7 @@
           <a:lstStyle xmlns:a="http://schemas.openxmlformats.org/drawingml/2006/main"/>
           <a:p xmlns:a="http://schemas.openxmlformats.org/drawingml/2006/main">
             <a:r>
-              <a:t>Result: four-track width MAE improves 13.1%, worst-track MAE 28.9%, and boundary MAE 17.6%.</a:t>
+              <a:t>Result: offline four-track width MAE improves 20.7%, worst-track MAE 34.8%, and boundary MAE 21.1%.</a:t>
             </a:r>
           </a:p>
           <a:p xmlns:a="http://schemas.openxmlformats.org/drawingml/2006/main">
@@ -1314,7 +1314,7 @@
           <a:lstStyle xmlns:a="http://schemas.openxmlformats.org/drawingml/2006/main"/>
           <a:p xmlns:a="http://schemas.openxmlformats.org/drawingml/2006/main">
             <a:r>
-              <a:t>Uncertainty: conditional intervals are narrower than global intervals and expand in difficult regions; SEM is not selected.</a:t>
+              <a:t>Uncertainty: conditional intervals are selected for the primary model; a separate causal ablation tests online potential.</a:t>
             </a:r>
           </a:p>
           <a:p xmlns:a="http://schemas.openxmlformats.org/drawingml/2006/main">
@@ -4410,17 +4410,17 @@
   </p:cSld>
   <p:clrMap bg1="lt1" tx1="dk1" bg2="lt2" tx2="dk2" accent1="accent1" accent2="accent2" accent3="accent3" accent4="accent4" accent5="accent5" accent6="accent6" hlink="hlink" folHlink="folHlink"/>
   <p:sldLayoutIdLst>
-    <p:sldLayoutId xmlns:r="http://schemas.openxmlformats.org/officeDocument/2006/relationships" id="2147483649" r:id="R5272c81493e143eb"/>
-    <p:sldLayoutId xmlns:r="http://schemas.openxmlformats.org/officeDocument/2006/relationships" id="2147483650" r:id="Rdad7bc45d6cd4555"/>
-    <p:sldLayoutId xmlns:r="http://schemas.openxmlformats.org/officeDocument/2006/relationships" id="2147483651" r:id="R2e243703596f487b"/>
-    <p:sldLayoutId xmlns:r="http://schemas.openxmlformats.org/officeDocument/2006/relationships" id="2147483652" r:id="R7de3477ad73d4159"/>
-    <p:sldLayoutId xmlns:r="http://schemas.openxmlformats.org/officeDocument/2006/relationships" id="2147483653" r:id="R79c59bbcdfc9414b"/>
-    <p:sldLayoutId xmlns:r="http://schemas.openxmlformats.org/officeDocument/2006/relationships" id="2147483654" r:id="R11703f3563984d56"/>
-    <p:sldLayoutId xmlns:r="http://schemas.openxmlformats.org/officeDocument/2006/relationships" id="2147483655" r:id="R9a3025d9af924562"/>
-    <p:sldLayoutId xmlns:r="http://schemas.openxmlformats.org/officeDocument/2006/relationships" id="2147483656" r:id="R0cbe584dede14f68"/>
-    <p:sldLayoutId xmlns:r="http://schemas.openxmlformats.org/officeDocument/2006/relationships" id="2147483657" r:id="R78e52e452e3d45bc"/>
-    <p:sldLayoutId xmlns:r="http://schemas.openxmlformats.org/officeDocument/2006/relationships" id="2147483658" r:id="Ra444d6a164e54b1e"/>
-    <p:sldLayoutId xmlns:r="http://schemas.openxmlformats.org/officeDocument/2006/relationships" id="2147483659" r:id="R466083f4376a469d"/>
+    <p:sldLayoutId xmlns:r="http://schemas.openxmlformats.org/officeDocument/2006/relationships" id="2147483649" r:id="R648687f7ea324306"/>
+    <p:sldLayoutId xmlns:r="http://schemas.openxmlformats.org/officeDocument/2006/relationships" id="2147483650" r:id="R86e071bae65240ff"/>
+    <p:sldLayoutId xmlns:r="http://schemas.openxmlformats.org/officeDocument/2006/relationships" id="2147483651" r:id="R9c01f0340ed64904"/>
+    <p:sldLayoutId xmlns:r="http://schemas.openxmlformats.org/officeDocument/2006/relationships" id="2147483652" r:id="Re5eb403bec5d4ee8"/>
+    <p:sldLayoutId xmlns:r="http://schemas.openxmlformats.org/officeDocument/2006/relationships" id="2147483653" r:id="Rdbe9560fd1d8403e"/>
+    <p:sldLayoutId xmlns:r="http://schemas.openxmlformats.org/officeDocument/2006/relationships" id="2147483654" r:id="R88177cf81ac94af4"/>
+    <p:sldLayoutId xmlns:r="http://schemas.openxmlformats.org/officeDocument/2006/relationships" id="2147483655" r:id="Rb75e8343c94e41c2"/>
+    <p:sldLayoutId xmlns:r="http://schemas.openxmlformats.org/officeDocument/2006/relationships" id="2147483656" r:id="R3b8fd3519ac347a5"/>
+    <p:sldLayoutId xmlns:r="http://schemas.openxmlformats.org/officeDocument/2006/relationships" id="2147483657" r:id="R8ee1172ae654486d"/>
+    <p:sldLayoutId xmlns:r="http://schemas.openxmlformats.org/officeDocument/2006/relationships" id="2147483658" r:id="Rc18c642e55894d09"/>
+    <p:sldLayoutId xmlns:r="http://schemas.openxmlformats.org/officeDocument/2006/relationships" id="2147483659" r:id="Rfcaedb034074469a"/>
   </p:sldLayoutIdLst>
   <p:txStyles>
     <p:titleStyle>
@@ -5222,7 +5222,7 @@
                 <a:ea typeface="Arial"/>
                 <a:cs typeface="Arial"/>
               </a:rPr>
-              <a:t>Hierarchical condition baselines, local residuals, and nested four-track evaluation</a:t>
+              <a:t>Offline completed-sequence hierarchy with a causal ablation</a:t>
             </a:r>
           </a:p>
         </p:txBody>
@@ -5328,7 +5328,7 @@
                 <a:ea typeface="Arial"/>
                 <a:cs typeface="Arial"/>
               </a:rPr>
-              <a:t>Team Submission</a:t>
+              <a:t>Team NSF-CHUDS</a:t>
             </a:r>
           </a:p>
           <a:p xmlns:a="http://schemas.openxmlformats.org/drawingml/2006/main">
@@ -5796,7 +5796,7 @@
                 <a:ea typeface="Arial"/>
                 <a:cs typeface="Arial"/>
               </a:rPr>
-              <a:t>Width MAE falls 13.1%; worst-track error falls 28.9%; boundary MAE falls 17.6%.</a:t>
+              <a:t>Width MAE falls 20.7%; worst-track error falls 34.8%; boundary MAE falls 21.1%.</a:t>
             </a:r>
           </a:p>
         </p:txBody>
@@ -6273,7 +6273,7 @@
                 <a:ea typeface="Arial"/>
                 <a:cs typeface="Arial"/>
               </a:rPr>
-              <a:t>Conditional intervals reach 91.4% coverage and expand in difficult regions.</a:t>
+              <a:t>Conditional intervals reach 93.5% and expand in difficult regions.</a:t>
             </a:r>
           </a:p>
         </p:txBody>
@@ -6454,7 +6454,7 @@
         <p:spPr>
           <a:xfrm xmlns:a="http://schemas.openxmlformats.org/drawingml/2006/main">
             <a:off x="1005840" y="5623560"/>
-            <a:ext cx="10241280" cy="365760"/>
+            <a:ext cx="10241280" cy="384048"/>
           </a:xfrm>
           <a:prstGeom xmlns:a="http://schemas.openxmlformats.org/drawingml/2006/main" prst="rect">
             <a:avLst/>
@@ -6485,7 +6485,8 @@
                 <a:ea typeface="Arial"/>
                 <a:cs typeface="Arial"/>
               </a:rPr>
-              <a:t>Questions?  |  github.com/alphons3t/nsf-chuds  |  github.com/joeyperez1-debug/nsfsubmit</a:t>
+              <a:t>Questions?  |  github.com/alphons3t/nsf-chuds  |  github.com/joeyperez1-debug/nsfsubmit
+Generative AI assisted code review, testing, debugging, and layout; measurements were not created or altered by AI.</a:t>
             </a:r>
           </a:p>
         </p:txBody>
@@ -7348,7 +7349,7 @@
                 <a:ea typeface="Arial"/>
                 <a:cs typeface="Arial"/>
               </a:rPr>
-              <a:t>Inputs: thermal history; post-process SEM tested separately</a:t>
+              <a:t>Inputs: completed thermal sequence only</a:t>
             </a:r>
           </a:p>
           <a:p xmlns:a="http://schemas.openxmlformats.org/drawingml/2006/main">
@@ -7902,7 +7903,7 @@
         <p:spPr>
           <a:xfrm xmlns:a="http://schemas.openxmlformats.org/drawingml/2006/main">
             <a:off x="594360" y="2880360"/>
-            <a:ext cx="3240938" cy="4572000"/>
+            <a:ext cx="3240938" cy="2857500"/>
           </a:xfrm>
           <a:prstGeom xmlns:a="http://schemas.openxmlformats.org/drawingml/2006/main" prst="rect">
             <a:avLst/>
@@ -8105,7 +8106,7 @@
                 <a:ea typeface="Georgia"/>
                 <a:cs typeface="Georgia"/>
               </a:rPr>
-              <a:t>Post-process SEM ablation</a:t>
+              <a:t>Post-process SEM audit</a:t>
             </a:r>
           </a:p>
         </p:txBody>
@@ -8127,7 +8128,7 @@
         <p:spPr>
           <a:xfrm xmlns:a="http://schemas.openxmlformats.org/drawingml/2006/main">
             <a:off x="4292498" y="2880360"/>
-            <a:ext cx="3240938" cy="4572000"/>
+            <a:ext cx="3240938" cy="2857500"/>
           </a:xfrm>
           <a:prstGeom xmlns:a="http://schemas.openxmlformats.org/drawingml/2006/main" prst="rect">
             <a:avLst/>
@@ -8180,7 +8181,7 @@
                 <a:ea typeface="Arial"/>
                 <a:cs typeface="Arial"/>
               </a:rPr>
-              <a:t>The processed center band is masked.</a:t>
+              <a:t>Unavailable at frame-time inference.</a:t>
             </a:r>
           </a:p>
           <a:p xmlns:a="http://schemas.openxmlformats.org/drawingml/2006/main">
@@ -8202,7 +8203,7 @@
                 <a:ea typeface="Arial"/>
                 <a:cs typeface="Arial"/>
               </a:rPr>
-              <a:t>Flank texture is tested, not assumed causal.</a:t>
+              <a:t>Excluded from predictive candidates.</a:t>
             </a:r>
           </a:p>
           <a:p xmlns:a="http://schemas.openxmlformats.org/drawingml/2006/main">
@@ -8224,7 +8225,7 @@
                 <a:ea typeface="Arial"/>
                 <a:cs typeface="Arial"/>
               </a:rPr>
-              <a:t>Selected in zero outer folds.</a:t>
+              <a:t>No causal substrate claim.</a:t>
             </a:r>
           </a:p>
         </p:txBody>
@@ -8405,7 +8406,7 @@
         <p:spPr>
           <a:xfrm xmlns:a="http://schemas.openxmlformats.org/drawingml/2006/main">
             <a:off x="7990636" y="2880360"/>
-            <a:ext cx="3240938" cy="4572000"/>
+            <a:ext cx="3240938" cy="2857500"/>
           </a:xfrm>
           <a:prstGeom xmlns:a="http://schemas.openxmlformats.org/drawingml/2006/main" prst="rect">
             <a:avLst/>
@@ -10284,7 +10285,7 @@
                 <a:ea typeface="Arial"/>
                 <a:cs typeface="Arial"/>
               </a:rPr>
-              <a:t>Audit rule: geometry, feature choice, model choice, and uncertainty calibration never see the current outer track. Generative AI assisted coding and layout; it did not alter measurements.</a:t>
+              <a:t>Audit rule: no held-out geometry, test-track labels, or post-process SEM enters prediction or selection. The primary model is offline; the causal ablation forbids future frames.</a:t>
             </a:r>
           </a:p>
         </p:txBody>
@@ -10869,7 +10870,7 @@
         <p:spPr>
           <a:xfrm xmlns:a="http://schemas.openxmlformats.org/drawingml/2006/main">
             <a:off x="594360" y="3246120"/>
-            <a:ext cx="5090007" cy="4572000"/>
+            <a:ext cx="5090007" cy="2667000"/>
           </a:xfrm>
           <a:prstGeom xmlns:a="http://schemas.openxmlformats.org/drawingml/2006/main" prst="rect">
             <a:avLst/>
@@ -11147,7 +11148,7 @@
         <p:spPr>
           <a:xfrm xmlns:a="http://schemas.openxmlformats.org/drawingml/2006/main">
             <a:off x="6370167" y="3246120"/>
-            <a:ext cx="5090007" cy="4572000"/>
+            <a:ext cx="5090007" cy="2667000"/>
           </a:xfrm>
           <a:prstGeom xmlns:a="http://schemas.openxmlformats.org/drawingml/2006/main" prst="rect">
             <a:avLst/>
@@ -11882,7 +11883,7 @@
         <p:spPr>
           <a:xfrm xmlns:a="http://schemas.openxmlformats.org/drawingml/2006/main">
             <a:off x="594360" y="3291840"/>
-            <a:ext cx="5090007" cy="4572000"/>
+            <a:ext cx="5090007" cy="2667000"/>
           </a:xfrm>
           <a:prstGeom xmlns:a="http://schemas.openxmlformats.org/drawingml/2006/main" prst="rect">
             <a:avLst/>
@@ -12160,7 +12161,7 @@
         <p:spPr>
           <a:xfrm xmlns:a="http://schemas.openxmlformats.org/drawingml/2006/main">
             <a:off x="6370167" y="3291840"/>
-            <a:ext cx="5090007" cy="4572000"/>
+            <a:ext cx="5090007" cy="2667000"/>
           </a:xfrm>
           <a:prstGeom xmlns:a="http://schemas.openxmlformats.org/drawingml/2006/main" prst="rect">
             <a:avLst/>
@@ -12191,7 +12192,7 @@
                 <a:ea typeface="Arial"/>
                 <a:cs typeface="Arial"/>
               </a:rPr>
-              <a:t>Track summaries predict baseline center and log-width.</a:t>
+              <a:t>Full-sequence summaries predict baseline center and log-width.</a:t>
             </a:r>
           </a:p>
           <a:p xmlns:a="http://schemas.openxmlformats.org/drawingml/2006/main">
@@ -12213,7 +12214,7 @@
                 <a:ea typeface="Arial"/>
                 <a:cs typeface="Arial"/>
               </a:rPr>
-              <a:t>Local history jointly predicts center and log-width residuals.</a:t>
+              <a:t>Frame history jointly predicts center and log-width residuals.</a:t>
             </a:r>
           </a:p>
           <a:p xmlns:a="http://schemas.openxmlformats.org/drawingml/2006/main">
@@ -12257,7 +12258,7 @@
                 <a:ea typeface="Arial"/>
                 <a:cs typeface="Arial"/>
               </a:rPr>
-              <a:t>Nested folds choose Ridge, elastic net, PLS, spline, or GP.</a:t>
+              <a:t>Causal ablation swaps in expanding summaries.</a:t>
             </a:r>
           </a:p>
         </p:txBody>
@@ -12661,7 +12662,7 @@
                 <a:ea typeface="Georgia"/>
                 <a:cs typeface="Georgia"/>
               </a:rPr>
-              <a:t>Four-track MAE falls 13.1% while boundaries improve</a:t>
+              <a:t>Offline four-track MAE falls 20.7%</a:t>
             </a:r>
           </a:p>
         </p:txBody>
@@ -12836,7 +12837,7 @@
           <p:nvPr/>
         </p:nvPicPr>
         <p:blipFill>
-          <a:blip xmlns:r="http://schemas.openxmlformats.org/officeDocument/2006/relationships" xmlns:a="http://schemas.openxmlformats.org/drawingml/2006/main" r:embed="R7436dbe109274010"/>
+          <a:blip xmlns:r="http://schemas.openxmlformats.org/officeDocument/2006/relationships" xmlns:a="http://schemas.openxmlformats.org/drawingml/2006/main" r:embed="Rcfc10e0ebdbe4861"/>
           <a:stretch xmlns:a="http://schemas.openxmlformats.org/drawingml/2006/main">
             <a:fillRect l="0" t="0" r="0" b="0"/>
           </a:stretch>
@@ -12899,7 +12900,7 @@
                 <a:ea typeface="Georgia"/>
                 <a:cs typeface="Georgia"/>
               </a:rPr>
-              <a:t>163 µm</a:t>
+              <a:t>148 µm</a:t>
             </a:r>
           </a:p>
           <a:p xmlns:a="http://schemas.openxmlformats.org/drawingml/2006/main">
@@ -12974,7 +12975,7 @@
                 <a:ea typeface="Georgia"/>
                 <a:cs typeface="Georgia"/>
               </a:rPr>
-              <a:t>13.1% lower</a:t>
+              <a:t>20.7% lower</a:t>
             </a:r>
           </a:p>
           <a:p xmlns:a="http://schemas.openxmlformats.org/drawingml/2006/main">
@@ -13124,7 +13125,7 @@
         <p:spPr>
           <a:xfrm xmlns:a="http://schemas.openxmlformats.org/drawingml/2006/main">
             <a:off x="6629400" y="3200400"/>
-            <a:ext cx="4937760" cy="4572000"/>
+            <a:ext cx="4937760" cy="2476500"/>
           </a:xfrm>
           <a:prstGeom xmlns:a="http://schemas.openxmlformats.org/drawingml/2006/main" prst="rect">
             <a:avLst/>
@@ -13155,7 +13156,7 @@
                 <a:ea typeface="Arial"/>
                 <a:cs typeface="Arial"/>
               </a:rPr>
-              <a:t>Track-balanced width MAE: 0.187 → 0.163 mm.</a:t>
+              <a:t>Track-balanced width MAE: 0.187 → 0.148 mm.</a:t>
             </a:r>
           </a:p>
           <a:p xmlns:a="http://schemas.openxmlformats.org/drawingml/2006/main">
@@ -13177,7 +13178,7 @@
                 <a:ea typeface="Arial"/>
                 <a:cs typeface="Arial"/>
               </a:rPr>
-              <a:t>Worst-track MAE: 0.308 → 0.219 mm.</a:t>
+              <a:t>Worst-track MAE: 0.308 → 0.201 mm.</a:t>
             </a:r>
           </a:p>
           <a:p xmlns:a="http://schemas.openxmlformats.org/drawingml/2006/main">
@@ -13199,7 +13200,7 @@
                 <a:ea typeface="Arial"/>
                 <a:cs typeface="Arial"/>
               </a:rPr>
-              <a:t>Mean boundary MAE: 0.180 → 0.148 mm.</a:t>
+              <a:t>Mean boundary MAE: 0.180 → 0.142 mm.</a:t>
             </a:r>
           </a:p>
           <a:p xmlns:a="http://schemas.openxmlformats.org/drawingml/2006/main">
@@ -13221,7 +13222,7 @@
                 <a:ea typeface="Arial"/>
                 <a:cs typeface="Arial"/>
               </a:rPr>
-              <a:t>Residual correlation: 0.055 → 0.124.</a:t>
+              <a:t>Track-balanced R²: -0.55 → -0.13.</a:t>
             </a:r>
           </a:p>
         </p:txBody>
@@ -13747,7 +13748,7 @@
           <p:nvPr/>
         </p:nvPicPr>
         <p:blipFill>
-          <a:blip xmlns:r="http://schemas.openxmlformats.org/officeDocument/2006/relationships" xmlns:a="http://schemas.openxmlformats.org/drawingml/2006/main" r:embed="Rc4f6e0b2f37f4a50"/>
+          <a:blip xmlns:r="http://schemas.openxmlformats.org/officeDocument/2006/relationships" xmlns:a="http://schemas.openxmlformats.org/drawingml/2006/main" r:embed="R4458217e47004c3d"/>
           <a:stretch xmlns:a="http://schemas.openxmlformats.org/drawingml/2006/main">
             <a:fillRect l="0" t="0" r="0" b="0"/>
           </a:stretch>
@@ -14022,7 +14023,7 @@
                 <a:ea typeface="Arial"/>
                 <a:cs typeface="Arial"/>
               </a:rPr>
-              <a:t>1. Predicted variation grows from 21% to 36% of measured scale.</a:t>
+              <a:t>1. Predicted variation grows from 21% to 32% of measured scale.</a:t>
             </a:r>
           </a:p>
           <a:p xmlns:a="http://schemas.openxmlformats.org/drawingml/2006/main">
@@ -14044,7 +14045,7 @@
                 <a:ea typeface="Arial"/>
                 <a:cs typeface="Arial"/>
               </a:rPr>
-              <a:t>2. Conditional intervals cover 91.4% at 0.738 mm mean width.</a:t>
+              <a:t>2. Conditional intervals cover 93.5% at 0.780 mm mean width.</a:t>
             </a:r>
           </a:p>
           <a:p xmlns:a="http://schemas.openxmlformats.org/drawingml/2006/main">
@@ -14066,7 +14067,7 @@
                 <a:ea typeface="Arial"/>
                 <a:cs typeface="Arial"/>
               </a:rPr>
-              <a:t>3. Global intervals cover 94.2% but are wider at 0.824 mm.</a:t>
+              <a:t>3. Global intervals cover 94.9% but are wider at 0.877 mm.</a:t>
             </a:r>
           </a:p>
           <a:p xmlns:a="http://schemas.openxmlformats.org/drawingml/2006/main">
@@ -14088,7 +14089,7 @@
                 <a:ea typeface="Arial"/>
                 <a:cs typeface="Arial"/>
               </a:rPr>
-              <a:t>4. Width expands from 0.610 mm easy to 0.912 mm hard.</a:t>
+              <a:t>4. Width expands from 0.629 mm easy to 0.944 mm hard.</a:t>
             </a:r>
           </a:p>
         </p:txBody>
@@ -14545,7 +14546,7 @@
                 <a:ea typeface="Arial"/>
                 <a:cs typeface="Arial"/>
               </a:rPr>
-              <a:t>Track-balanced R² is -0.34; local predictions still miss structure.</a:t>
+              <a:t>Primary R² improves from -0.55 to -0.13 but remains negative.</a:t>
             </a:r>
           </a:p>
           <a:p xmlns:a="http://schemas.openxmlformats.org/drawingml/2006/main">
@@ -14567,7 +14568,7 @@
                 <a:ea typeface="Arial"/>
                 <a:cs typeface="Arial"/>
               </a:rPr>
-              <a:t>Four tracks cannot establish stability across plates or recipes.</a:t>
+              <a:t>Primary mode is offline after the thermal scan completes.</a:t>
             </a:r>
           </a:p>
           <a:p xmlns:a="http://schemas.openxmlformats.org/drawingml/2006/main">
@@ -14589,7 +14590,7 @@
                 <a:ea typeface="Arial"/>
                 <a:cs typeface="Arial"/>
               </a:rPr>
-              <a:t>Nested Track 21 MAE is 0.219 mm; the prior 0.139 mm is historical only.</a:t>
+              <a:t>Causal ablation: 0.157 mm MAE and -0.18 R².</a:t>
             </a:r>
           </a:p>
           <a:p xmlns:a="http://schemas.openxmlformats.org/drawingml/2006/main">
@@ -14611,7 +14612,7 @@
                 <a:ea typeface="Arial"/>
                 <a:cs typeface="Arial"/>
               </a:rPr>
-              <a:t>Post-process SEM is selected in zero folds.</a:t>
+              <a:t>Post-process SEM is excluded from prediction.</a:t>
             </a:r>
           </a:p>
           <a:p xmlns:a="http://schemas.openxmlformats.org/drawingml/2006/main">
@@ -14633,7 +14634,7 @@
                 <a:ea typeface="Arial"/>
                 <a:cs typeface="Arial"/>
               </a:rPr>
-              <a:t>No causal substrate claim is supported.</a:t>
+              <a:t>No closed-loop or causal substrate claim.</a:t>
             </a:r>
           </a:p>
         </p:txBody>

</xml_diff>